<commit_message>
Deck: rework aim slide, add presenter + Adobe footer on every slide
- Title slide: add presenter "Prince Parvat — Technical Product Consultant 3"
- Slide 2 reworked: reframed as understanding the flow + routing cases (Web SDK
  missing hit/not ingested, Mobile SDK, Assurance, failed batch, guiding the
  customer, deciding owner) and what the project gives; scope note that AEP
  support does not debug Data Collection implementations
- Footer "© 2026 Adobe. All Rights Reserved. Adobe Confidential." + slide number
  on all 23 slides (matches template)

Co-Authored-By: Claude Opus 4.8 <noreply@anthropic.com>
</commit_message>
<xml_diff>
--- a/presentation/Feastly-DataCollection-to-AEP.pptx
+++ b/presentation/Feastly-DataCollection-to-AEP.pptx
@@ -1492,7 +1492,7 @@
           <a:p>
             <a:r>
               <a:rPr lang="en-US" dirty="0"/>
-              <a:t>Frame it as: you already debug AEP; this gives you the vocabulary and the map of the collection side so you can triage faster.</a:t>
+              <a:t>Reframe: this is NOT about us debugging Data Collection. It is about understanding how data reaches AEP so we can investigate, guide the customer, and decide the right owning team (us / Data Collection / Analytics). The scenarios on the left are exactly the judgement calls we make.</a:t>
             </a:r>
             <a:endParaRPr lang="en-US" dirty="0"/>
           </a:p>
@@ -3044,8 +3044,8 @@
         </p:nvSpPr>
         <p:spPr>
           <a:xfrm>
-            <a:off x="548640" y="5943600"/>
-            <a:ext cx="8229600" cy="365760"/>
+            <a:off x="548640" y="5212080"/>
+            <a:ext cx="8229600" cy="274320"/>
           </a:xfrm>
           <a:prstGeom prst="rect">
             <a:avLst/>
@@ -3061,7 +3061,7 @@
               <a:buNone/>
             </a:pPr>
             <a:r>
-              <a:rPr lang="en-US" sz="1300" i="1" dirty="0">
+              <a:rPr lang="en-US" sz="1200" dirty="0">
                 <a:solidFill>
                   <a:srgbClr val="9B9B9B"/>
                 </a:solidFill>
@@ -3069,9 +3069,165 @@
                 <a:ea typeface="Adobe Clean" pitchFamily="34" charset="-122"/>
                 <a:cs typeface="Adobe Clean" pitchFamily="34" charset="-120"/>
               </a:rPr>
-              <a:t>A hands-on demo for the AEP Support team</a:t>
-            </a:r>
-            <a:endParaRPr lang="en-US" sz="1300" dirty="0"/>
+              <a:t>Presented by</a:t>
+            </a:r>
+            <a:endParaRPr lang="en-US" sz="1200" dirty="0"/>
+          </a:p>
+        </p:txBody>
+      </p:sp>
+      <p:sp>
+        <p:nvSpPr>
+          <p:cNvPr id="9" name="Text 7"/>
+          <p:cNvSpPr txBox="1"/>
+          <p:nvPr/>
+        </p:nvSpPr>
+        <p:spPr>
+          <a:xfrm>
+            <a:off x="548640" y="5468112"/>
+            <a:ext cx="8229600" cy="411480"/>
+          </a:xfrm>
+          <a:prstGeom prst="rect">
+            <a:avLst/>
+          </a:prstGeom>
+          <a:noFill/>
+          <a:ln/>
+        </p:spPr>
+        <p:txBody>
+          <a:bodyPr wrap="square" lIns="0" tIns="0" rIns="0" bIns="0" rtlCol="0" anchor="ctr"/>
+          <a:lstStyle/>
+          <a:p>
+            <a:pPr indent="0" marL="0">
+              <a:buNone/>
+            </a:pPr>
+            <a:r>
+              <a:rPr lang="en-US" sz="2200" b="1" dirty="0">
+                <a:solidFill>
+                  <a:srgbClr val="FFFFFF"/>
+                </a:solidFill>
+                <a:latin typeface="Adobe Clean" pitchFamily="34" charset="0"/>
+                <a:ea typeface="Adobe Clean" pitchFamily="34" charset="-122"/>
+                <a:cs typeface="Adobe Clean" pitchFamily="34" charset="-120"/>
+              </a:rPr>
+              <a:t>Prince Parvat</a:t>
+            </a:r>
+            <a:endParaRPr lang="en-US" sz="2200" dirty="0"/>
+          </a:p>
+        </p:txBody>
+      </p:sp>
+      <p:sp>
+        <p:nvSpPr>
+          <p:cNvPr id="10" name="Text 8"/>
+          <p:cNvSpPr txBox="1"/>
+          <p:nvPr/>
+        </p:nvSpPr>
+        <p:spPr>
+          <a:xfrm>
+            <a:off x="548640" y="5907024"/>
+            <a:ext cx="8229600" cy="320040"/>
+          </a:xfrm>
+          <a:prstGeom prst="rect">
+            <a:avLst/>
+          </a:prstGeom>
+          <a:noFill/>
+          <a:ln/>
+        </p:spPr>
+        <p:txBody>
+          <a:bodyPr wrap="square" lIns="0" tIns="0" rIns="0" bIns="0" rtlCol="0" anchor="ctr"/>
+          <a:lstStyle/>
+          <a:p>
+            <a:pPr indent="0" marL="0">
+              <a:buNone/>
+            </a:pPr>
+            <a:r>
+              <a:rPr lang="en-US" sz="1400" dirty="0">
+                <a:solidFill>
+                  <a:srgbClr val="FFA311"/>
+                </a:solidFill>
+                <a:latin typeface="Adobe Clean" pitchFamily="34" charset="0"/>
+                <a:ea typeface="Adobe Clean" pitchFamily="34" charset="-122"/>
+                <a:cs typeface="Adobe Clean" pitchFamily="34" charset="-120"/>
+              </a:rPr>
+              <a:t>Technical Product Consultant 3</a:t>
+            </a:r>
+            <a:endParaRPr lang="en-US" sz="1400" dirty="0"/>
+          </a:p>
+        </p:txBody>
+      </p:sp>
+      <p:sp>
+        <p:nvSpPr>
+          <p:cNvPr id="12" name="Text 9"/>
+          <p:cNvSpPr txBox="1"/>
+          <p:nvPr/>
+        </p:nvSpPr>
+        <p:spPr>
+          <a:xfrm>
+            <a:off x="457200" y="6473952"/>
+            <a:ext cx="8686800" cy="274320"/>
+          </a:xfrm>
+          <a:prstGeom prst="rect">
+            <a:avLst/>
+          </a:prstGeom>
+          <a:noFill/>
+          <a:ln/>
+        </p:spPr>
+        <p:txBody>
+          <a:bodyPr wrap="square" lIns="0" tIns="0" rIns="0" bIns="0" rtlCol="0" anchor="ctr"/>
+          <a:lstStyle/>
+          <a:p>
+            <a:pPr indent="0" marL="0">
+              <a:buNone/>
+            </a:pPr>
+            <a:r>
+              <a:rPr lang="en-US" sz="900" dirty="0">
+                <a:solidFill>
+                  <a:srgbClr val="8A8A8A"/>
+                </a:solidFill>
+                <a:latin typeface="Adobe Clean" pitchFamily="34" charset="0"/>
+                <a:ea typeface="Adobe Clean" pitchFamily="34" charset="-122"/>
+                <a:cs typeface="Adobe Clean" pitchFamily="34" charset="-120"/>
+              </a:rPr>
+              <a:t>© 2026 Adobe. All Rights Reserved. Adobe Confidential.</a:t>
+            </a:r>
+            <a:endParaRPr lang="en-US" sz="900" dirty="0"/>
+          </a:p>
+        </p:txBody>
+      </p:sp>
+      <p:sp>
+        <p:nvSpPr>
+          <p:cNvPr id="13" name="Text 10"/>
+          <p:cNvSpPr txBox="1"/>
+          <p:nvPr/>
+        </p:nvSpPr>
+        <p:spPr>
+          <a:xfrm>
+            <a:off x="11155680" y="6473952"/>
+            <a:ext cx="640080" cy="274320"/>
+          </a:xfrm>
+          <a:prstGeom prst="rect">
+            <a:avLst/>
+          </a:prstGeom>
+          <a:noFill/>
+          <a:ln/>
+        </p:spPr>
+        <p:txBody>
+          <a:bodyPr wrap="square" lIns="0" tIns="0" rIns="0" bIns="0" rtlCol="0" anchor="ctr"/>
+          <a:lstStyle/>
+          <a:p>
+            <a:pPr algn="r" indent="0" marL="0">
+              <a:buNone/>
+            </a:pPr>
+            <a:r>
+              <a:rPr lang="en-US" sz="900" dirty="0">
+                <a:solidFill>
+                  <a:srgbClr val="8A8A8A"/>
+                </a:solidFill>
+                <a:latin typeface="Adobe Clean" pitchFamily="34" charset="0"/>
+                <a:ea typeface="Adobe Clean" pitchFamily="34" charset="-122"/>
+                <a:cs typeface="Adobe Clean" pitchFamily="34" charset="-120"/>
+              </a:rPr>
+              <a:t>1</a:t>
+            </a:r>
+            <a:endParaRPr lang="en-US" sz="900" dirty="0"/>
           </a:p>
         </p:txBody>
       </p:sp>
@@ -4327,6 +4483,84 @@
           </a:p>
         </p:txBody>
       </p:sp>
+      <p:sp>
+        <p:nvSpPr>
+          <p:cNvPr id="36" name="Text 33"/>
+          <p:cNvSpPr txBox="1"/>
+          <p:nvPr/>
+        </p:nvSpPr>
+        <p:spPr>
+          <a:xfrm>
+            <a:off x="457200" y="6473952"/>
+            <a:ext cx="8686800" cy="274320"/>
+          </a:xfrm>
+          <a:prstGeom prst="rect">
+            <a:avLst/>
+          </a:prstGeom>
+          <a:noFill/>
+          <a:ln/>
+        </p:spPr>
+        <p:txBody>
+          <a:bodyPr wrap="square" lIns="0" tIns="0" rIns="0" bIns="0" rtlCol="0" anchor="ctr"/>
+          <a:lstStyle/>
+          <a:p>
+            <a:pPr indent="0" marL="0">
+              <a:buNone/>
+            </a:pPr>
+            <a:r>
+              <a:rPr lang="en-US" sz="900" dirty="0">
+                <a:solidFill>
+                  <a:srgbClr val="A3A3A3"/>
+                </a:solidFill>
+                <a:latin typeface="Adobe Clean" pitchFamily="34" charset="0"/>
+                <a:ea typeface="Adobe Clean" pitchFamily="34" charset="-122"/>
+                <a:cs typeface="Adobe Clean" pitchFamily="34" charset="-120"/>
+              </a:rPr>
+              <a:t>© 2026 Adobe. All Rights Reserved. Adobe Confidential.</a:t>
+            </a:r>
+            <a:endParaRPr lang="en-US" sz="900" dirty="0"/>
+          </a:p>
+        </p:txBody>
+      </p:sp>
+      <p:sp>
+        <p:nvSpPr>
+          <p:cNvPr id="37" name="Text 34"/>
+          <p:cNvSpPr txBox="1"/>
+          <p:nvPr/>
+        </p:nvSpPr>
+        <p:spPr>
+          <a:xfrm>
+            <a:off x="11155680" y="6473952"/>
+            <a:ext cx="640080" cy="274320"/>
+          </a:xfrm>
+          <a:prstGeom prst="rect">
+            <a:avLst/>
+          </a:prstGeom>
+          <a:noFill/>
+          <a:ln/>
+        </p:spPr>
+        <p:txBody>
+          <a:bodyPr wrap="square" lIns="0" tIns="0" rIns="0" bIns="0" rtlCol="0" anchor="ctr"/>
+          <a:lstStyle/>
+          <a:p>
+            <a:pPr algn="r" indent="0" marL="0">
+              <a:buNone/>
+            </a:pPr>
+            <a:r>
+              <a:rPr lang="en-US" sz="900" dirty="0">
+                <a:solidFill>
+                  <a:srgbClr val="A3A3A3"/>
+                </a:solidFill>
+                <a:latin typeface="Adobe Clean" pitchFamily="34" charset="0"/>
+                <a:ea typeface="Adobe Clean" pitchFamily="34" charset="-122"/>
+                <a:cs typeface="Adobe Clean" pitchFamily="34" charset="-120"/>
+              </a:rPr>
+              <a:t>10</a:t>
+            </a:r>
+            <a:endParaRPr lang="en-US" sz="900" dirty="0"/>
+          </a:p>
+        </p:txBody>
+      </p:sp>
     </p:spTree>
   </p:cSld>
   <p:clrMapOvr>
@@ -5140,6 +5374,84 @@
           </a:p>
         </p:txBody>
       </p:sp>
+      <p:sp>
+        <p:nvSpPr>
+          <p:cNvPr id="24" name="Text 21"/>
+          <p:cNvSpPr txBox="1"/>
+          <p:nvPr/>
+        </p:nvSpPr>
+        <p:spPr>
+          <a:xfrm>
+            <a:off x="457200" y="6473952"/>
+            <a:ext cx="8686800" cy="274320"/>
+          </a:xfrm>
+          <a:prstGeom prst="rect">
+            <a:avLst/>
+          </a:prstGeom>
+          <a:noFill/>
+          <a:ln/>
+        </p:spPr>
+        <p:txBody>
+          <a:bodyPr wrap="square" lIns="0" tIns="0" rIns="0" bIns="0" rtlCol="0" anchor="ctr"/>
+          <a:lstStyle/>
+          <a:p>
+            <a:pPr indent="0" marL="0">
+              <a:buNone/>
+            </a:pPr>
+            <a:r>
+              <a:rPr lang="en-US" sz="900" dirty="0">
+                <a:solidFill>
+                  <a:srgbClr val="8A8A8A"/>
+                </a:solidFill>
+                <a:latin typeface="Adobe Clean" pitchFamily="34" charset="0"/>
+                <a:ea typeface="Adobe Clean" pitchFamily="34" charset="-122"/>
+                <a:cs typeface="Adobe Clean" pitchFamily="34" charset="-120"/>
+              </a:rPr>
+              <a:t>© 2026 Adobe. All Rights Reserved. Adobe Confidential.</a:t>
+            </a:r>
+            <a:endParaRPr lang="en-US" sz="900" dirty="0"/>
+          </a:p>
+        </p:txBody>
+      </p:sp>
+      <p:sp>
+        <p:nvSpPr>
+          <p:cNvPr id="25" name="Text 22"/>
+          <p:cNvSpPr txBox="1"/>
+          <p:nvPr/>
+        </p:nvSpPr>
+        <p:spPr>
+          <a:xfrm>
+            <a:off x="11155680" y="6473952"/>
+            <a:ext cx="640080" cy="274320"/>
+          </a:xfrm>
+          <a:prstGeom prst="rect">
+            <a:avLst/>
+          </a:prstGeom>
+          <a:noFill/>
+          <a:ln/>
+        </p:spPr>
+        <p:txBody>
+          <a:bodyPr wrap="square" lIns="0" tIns="0" rIns="0" bIns="0" rtlCol="0" anchor="ctr"/>
+          <a:lstStyle/>
+          <a:p>
+            <a:pPr algn="r" indent="0" marL="0">
+              <a:buNone/>
+            </a:pPr>
+            <a:r>
+              <a:rPr lang="en-US" sz="900" dirty="0">
+                <a:solidFill>
+                  <a:srgbClr val="8A8A8A"/>
+                </a:solidFill>
+                <a:latin typeface="Adobe Clean" pitchFamily="34" charset="0"/>
+                <a:ea typeface="Adobe Clean" pitchFamily="34" charset="-122"/>
+                <a:cs typeface="Adobe Clean" pitchFamily="34" charset="-120"/>
+              </a:rPr>
+              <a:t>11</a:t>
+            </a:r>
+            <a:endParaRPr lang="en-US" sz="900" dirty="0"/>
+          </a:p>
+        </p:txBody>
+      </p:sp>
     </p:spTree>
   </p:cSld>
   <p:clrMapOvr>
@@ -5911,6 +6223,84 @@
           </a:p>
         </p:txBody>
       </p:sp>
+      <p:sp>
+        <p:nvSpPr>
+          <p:cNvPr id="24" name="Text 21"/>
+          <p:cNvSpPr txBox="1"/>
+          <p:nvPr/>
+        </p:nvSpPr>
+        <p:spPr>
+          <a:xfrm>
+            <a:off x="457200" y="6473952"/>
+            <a:ext cx="8686800" cy="274320"/>
+          </a:xfrm>
+          <a:prstGeom prst="rect">
+            <a:avLst/>
+          </a:prstGeom>
+          <a:noFill/>
+          <a:ln/>
+        </p:spPr>
+        <p:txBody>
+          <a:bodyPr wrap="square" lIns="0" tIns="0" rIns="0" bIns="0" rtlCol="0" anchor="ctr"/>
+          <a:lstStyle/>
+          <a:p>
+            <a:pPr indent="0" marL="0">
+              <a:buNone/>
+            </a:pPr>
+            <a:r>
+              <a:rPr lang="en-US" sz="900" dirty="0">
+                <a:solidFill>
+                  <a:srgbClr val="A3A3A3"/>
+                </a:solidFill>
+                <a:latin typeface="Adobe Clean" pitchFamily="34" charset="0"/>
+                <a:ea typeface="Adobe Clean" pitchFamily="34" charset="-122"/>
+                <a:cs typeface="Adobe Clean" pitchFamily="34" charset="-120"/>
+              </a:rPr>
+              <a:t>© 2026 Adobe. All Rights Reserved. Adobe Confidential.</a:t>
+            </a:r>
+            <a:endParaRPr lang="en-US" sz="900" dirty="0"/>
+          </a:p>
+        </p:txBody>
+      </p:sp>
+      <p:sp>
+        <p:nvSpPr>
+          <p:cNvPr id="25" name="Text 22"/>
+          <p:cNvSpPr txBox="1"/>
+          <p:nvPr/>
+        </p:nvSpPr>
+        <p:spPr>
+          <a:xfrm>
+            <a:off x="11155680" y="6473952"/>
+            <a:ext cx="640080" cy="274320"/>
+          </a:xfrm>
+          <a:prstGeom prst="rect">
+            <a:avLst/>
+          </a:prstGeom>
+          <a:noFill/>
+          <a:ln/>
+        </p:spPr>
+        <p:txBody>
+          <a:bodyPr wrap="square" lIns="0" tIns="0" rIns="0" bIns="0" rtlCol="0" anchor="ctr"/>
+          <a:lstStyle/>
+          <a:p>
+            <a:pPr algn="r" indent="0" marL="0">
+              <a:buNone/>
+            </a:pPr>
+            <a:r>
+              <a:rPr lang="en-US" sz="900" dirty="0">
+                <a:solidFill>
+                  <a:srgbClr val="A3A3A3"/>
+                </a:solidFill>
+                <a:latin typeface="Adobe Clean" pitchFamily="34" charset="0"/>
+                <a:ea typeface="Adobe Clean" pitchFamily="34" charset="-122"/>
+                <a:cs typeface="Adobe Clean" pitchFamily="34" charset="-120"/>
+              </a:rPr>
+              <a:t>12</a:t>
+            </a:r>
+            <a:endParaRPr lang="en-US" sz="900" dirty="0"/>
+          </a:p>
+        </p:txBody>
+      </p:sp>
     </p:spTree>
   </p:cSld>
   <p:clrMapOvr>
@@ -6682,6 +7072,84 @@
           </a:p>
         </p:txBody>
       </p:sp>
+      <p:sp>
+        <p:nvSpPr>
+          <p:cNvPr id="24" name="Text 21"/>
+          <p:cNvSpPr txBox="1"/>
+          <p:nvPr/>
+        </p:nvSpPr>
+        <p:spPr>
+          <a:xfrm>
+            <a:off x="457200" y="6473952"/>
+            <a:ext cx="8686800" cy="274320"/>
+          </a:xfrm>
+          <a:prstGeom prst="rect">
+            <a:avLst/>
+          </a:prstGeom>
+          <a:noFill/>
+          <a:ln/>
+        </p:spPr>
+        <p:txBody>
+          <a:bodyPr wrap="square" lIns="0" tIns="0" rIns="0" bIns="0" rtlCol="0" anchor="ctr"/>
+          <a:lstStyle/>
+          <a:p>
+            <a:pPr indent="0" marL="0">
+              <a:buNone/>
+            </a:pPr>
+            <a:r>
+              <a:rPr lang="en-US" sz="900" dirty="0">
+                <a:solidFill>
+                  <a:srgbClr val="A3A3A3"/>
+                </a:solidFill>
+                <a:latin typeface="Adobe Clean" pitchFamily="34" charset="0"/>
+                <a:ea typeface="Adobe Clean" pitchFamily="34" charset="-122"/>
+                <a:cs typeface="Adobe Clean" pitchFamily="34" charset="-120"/>
+              </a:rPr>
+              <a:t>© 2026 Adobe. All Rights Reserved. Adobe Confidential.</a:t>
+            </a:r>
+            <a:endParaRPr lang="en-US" sz="900" dirty="0"/>
+          </a:p>
+        </p:txBody>
+      </p:sp>
+      <p:sp>
+        <p:nvSpPr>
+          <p:cNvPr id="25" name="Text 22"/>
+          <p:cNvSpPr txBox="1"/>
+          <p:nvPr/>
+        </p:nvSpPr>
+        <p:spPr>
+          <a:xfrm>
+            <a:off x="11155680" y="6473952"/>
+            <a:ext cx="640080" cy="274320"/>
+          </a:xfrm>
+          <a:prstGeom prst="rect">
+            <a:avLst/>
+          </a:prstGeom>
+          <a:noFill/>
+          <a:ln/>
+        </p:spPr>
+        <p:txBody>
+          <a:bodyPr wrap="square" lIns="0" tIns="0" rIns="0" bIns="0" rtlCol="0" anchor="ctr"/>
+          <a:lstStyle/>
+          <a:p>
+            <a:pPr algn="r" indent="0" marL="0">
+              <a:buNone/>
+            </a:pPr>
+            <a:r>
+              <a:rPr lang="en-US" sz="900" dirty="0">
+                <a:solidFill>
+                  <a:srgbClr val="A3A3A3"/>
+                </a:solidFill>
+                <a:latin typeface="Adobe Clean" pitchFamily="34" charset="0"/>
+                <a:ea typeface="Adobe Clean" pitchFamily="34" charset="-122"/>
+                <a:cs typeface="Adobe Clean" pitchFamily="34" charset="-120"/>
+              </a:rPr>
+              <a:t>13</a:t>
+            </a:r>
+            <a:endParaRPr lang="en-US" sz="900" dirty="0"/>
+          </a:p>
+        </p:txBody>
+      </p:sp>
     </p:spTree>
   </p:cSld>
   <p:clrMapOvr>
@@ -7453,6 +7921,84 @@
           </a:p>
         </p:txBody>
       </p:sp>
+      <p:sp>
+        <p:nvSpPr>
+          <p:cNvPr id="24" name="Text 21"/>
+          <p:cNvSpPr txBox="1"/>
+          <p:nvPr/>
+        </p:nvSpPr>
+        <p:spPr>
+          <a:xfrm>
+            <a:off x="457200" y="6473952"/>
+            <a:ext cx="8686800" cy="274320"/>
+          </a:xfrm>
+          <a:prstGeom prst="rect">
+            <a:avLst/>
+          </a:prstGeom>
+          <a:noFill/>
+          <a:ln/>
+        </p:spPr>
+        <p:txBody>
+          <a:bodyPr wrap="square" lIns="0" tIns="0" rIns="0" bIns="0" rtlCol="0" anchor="ctr"/>
+          <a:lstStyle/>
+          <a:p>
+            <a:pPr indent="0" marL="0">
+              <a:buNone/>
+            </a:pPr>
+            <a:r>
+              <a:rPr lang="en-US" sz="900" dirty="0">
+                <a:solidFill>
+                  <a:srgbClr val="A3A3A3"/>
+                </a:solidFill>
+                <a:latin typeface="Adobe Clean" pitchFamily="34" charset="0"/>
+                <a:ea typeface="Adobe Clean" pitchFamily="34" charset="-122"/>
+                <a:cs typeface="Adobe Clean" pitchFamily="34" charset="-120"/>
+              </a:rPr>
+              <a:t>© 2026 Adobe. All Rights Reserved. Adobe Confidential.</a:t>
+            </a:r>
+            <a:endParaRPr lang="en-US" sz="900" dirty="0"/>
+          </a:p>
+        </p:txBody>
+      </p:sp>
+      <p:sp>
+        <p:nvSpPr>
+          <p:cNvPr id="25" name="Text 22"/>
+          <p:cNvSpPr txBox="1"/>
+          <p:nvPr/>
+        </p:nvSpPr>
+        <p:spPr>
+          <a:xfrm>
+            <a:off x="11155680" y="6473952"/>
+            <a:ext cx="640080" cy="274320"/>
+          </a:xfrm>
+          <a:prstGeom prst="rect">
+            <a:avLst/>
+          </a:prstGeom>
+          <a:noFill/>
+          <a:ln/>
+        </p:spPr>
+        <p:txBody>
+          <a:bodyPr wrap="square" lIns="0" tIns="0" rIns="0" bIns="0" rtlCol="0" anchor="ctr"/>
+          <a:lstStyle/>
+          <a:p>
+            <a:pPr algn="r" indent="0" marL="0">
+              <a:buNone/>
+            </a:pPr>
+            <a:r>
+              <a:rPr lang="en-US" sz="900" dirty="0">
+                <a:solidFill>
+                  <a:srgbClr val="A3A3A3"/>
+                </a:solidFill>
+                <a:latin typeface="Adobe Clean" pitchFamily="34" charset="0"/>
+                <a:ea typeface="Adobe Clean" pitchFamily="34" charset="-122"/>
+                <a:cs typeface="Adobe Clean" pitchFamily="34" charset="-120"/>
+              </a:rPr>
+              <a:t>14</a:t>
+            </a:r>
+            <a:endParaRPr lang="en-US" sz="900" dirty="0"/>
+          </a:p>
+        </p:txBody>
+      </p:sp>
     </p:spTree>
   </p:cSld>
   <p:clrMapOvr>
@@ -8425,6 +8971,84 @@
           </a:p>
         </p:txBody>
       </p:sp>
+      <p:sp>
+        <p:nvSpPr>
+          <p:cNvPr id="32" name="Text 29"/>
+          <p:cNvSpPr txBox="1"/>
+          <p:nvPr/>
+        </p:nvSpPr>
+        <p:spPr>
+          <a:xfrm>
+            <a:off x="457200" y="6473952"/>
+            <a:ext cx="8686800" cy="274320"/>
+          </a:xfrm>
+          <a:prstGeom prst="rect">
+            <a:avLst/>
+          </a:prstGeom>
+          <a:noFill/>
+          <a:ln/>
+        </p:spPr>
+        <p:txBody>
+          <a:bodyPr wrap="square" lIns="0" tIns="0" rIns="0" bIns="0" rtlCol="0" anchor="ctr"/>
+          <a:lstStyle/>
+          <a:p>
+            <a:pPr indent="0" marL="0">
+              <a:buNone/>
+            </a:pPr>
+            <a:r>
+              <a:rPr lang="en-US" sz="900" dirty="0">
+                <a:solidFill>
+                  <a:srgbClr val="A3A3A3"/>
+                </a:solidFill>
+                <a:latin typeface="Adobe Clean" pitchFamily="34" charset="0"/>
+                <a:ea typeface="Adobe Clean" pitchFamily="34" charset="-122"/>
+                <a:cs typeface="Adobe Clean" pitchFamily="34" charset="-120"/>
+              </a:rPr>
+              <a:t>© 2026 Adobe. All Rights Reserved. Adobe Confidential.</a:t>
+            </a:r>
+            <a:endParaRPr lang="en-US" sz="900" dirty="0"/>
+          </a:p>
+        </p:txBody>
+      </p:sp>
+      <p:sp>
+        <p:nvSpPr>
+          <p:cNvPr id="33" name="Text 30"/>
+          <p:cNvSpPr txBox="1"/>
+          <p:nvPr/>
+        </p:nvSpPr>
+        <p:spPr>
+          <a:xfrm>
+            <a:off x="11155680" y="6473952"/>
+            <a:ext cx="640080" cy="274320"/>
+          </a:xfrm>
+          <a:prstGeom prst="rect">
+            <a:avLst/>
+          </a:prstGeom>
+          <a:noFill/>
+          <a:ln/>
+        </p:spPr>
+        <p:txBody>
+          <a:bodyPr wrap="square" lIns="0" tIns="0" rIns="0" bIns="0" rtlCol="0" anchor="ctr"/>
+          <a:lstStyle/>
+          <a:p>
+            <a:pPr algn="r" indent="0" marL="0">
+              <a:buNone/>
+            </a:pPr>
+            <a:r>
+              <a:rPr lang="en-US" sz="900" dirty="0">
+                <a:solidFill>
+                  <a:srgbClr val="A3A3A3"/>
+                </a:solidFill>
+                <a:latin typeface="Adobe Clean" pitchFamily="34" charset="0"/>
+                <a:ea typeface="Adobe Clean" pitchFamily="34" charset="-122"/>
+                <a:cs typeface="Adobe Clean" pitchFamily="34" charset="-120"/>
+              </a:rPr>
+              <a:t>15</a:t>
+            </a:r>
+            <a:endParaRPr lang="en-US" sz="900" dirty="0"/>
+          </a:p>
+        </p:txBody>
+      </p:sp>
     </p:spTree>
   </p:cSld>
   <p:clrMapOvr>
@@ -10312,6 +10936,84 @@
           </a:p>
         </p:txBody>
       </p:sp>
+      <p:sp>
+        <p:nvSpPr>
+          <p:cNvPr id="61" name="Text 58"/>
+          <p:cNvSpPr txBox="1"/>
+          <p:nvPr/>
+        </p:nvSpPr>
+        <p:spPr>
+          <a:xfrm>
+            <a:off x="457200" y="6473952"/>
+            <a:ext cx="8686800" cy="274320"/>
+          </a:xfrm>
+          <a:prstGeom prst="rect">
+            <a:avLst/>
+          </a:prstGeom>
+          <a:noFill/>
+          <a:ln/>
+        </p:spPr>
+        <p:txBody>
+          <a:bodyPr wrap="square" lIns="0" tIns="0" rIns="0" bIns="0" rtlCol="0" anchor="ctr"/>
+          <a:lstStyle/>
+          <a:p>
+            <a:pPr indent="0" marL="0">
+              <a:buNone/>
+            </a:pPr>
+            <a:r>
+              <a:rPr lang="en-US" sz="900" dirty="0">
+                <a:solidFill>
+                  <a:srgbClr val="A3A3A3"/>
+                </a:solidFill>
+                <a:latin typeface="Adobe Clean" pitchFamily="34" charset="0"/>
+                <a:ea typeface="Adobe Clean" pitchFamily="34" charset="-122"/>
+                <a:cs typeface="Adobe Clean" pitchFamily="34" charset="-120"/>
+              </a:rPr>
+              <a:t>© 2026 Adobe. All Rights Reserved. Adobe Confidential.</a:t>
+            </a:r>
+            <a:endParaRPr lang="en-US" sz="900" dirty="0"/>
+          </a:p>
+        </p:txBody>
+      </p:sp>
+      <p:sp>
+        <p:nvSpPr>
+          <p:cNvPr id="62" name="Text 59"/>
+          <p:cNvSpPr txBox="1"/>
+          <p:nvPr/>
+        </p:nvSpPr>
+        <p:spPr>
+          <a:xfrm>
+            <a:off x="11155680" y="6473952"/>
+            <a:ext cx="640080" cy="274320"/>
+          </a:xfrm>
+          <a:prstGeom prst="rect">
+            <a:avLst/>
+          </a:prstGeom>
+          <a:noFill/>
+          <a:ln/>
+        </p:spPr>
+        <p:txBody>
+          <a:bodyPr wrap="square" lIns="0" tIns="0" rIns="0" bIns="0" rtlCol="0" anchor="ctr"/>
+          <a:lstStyle/>
+          <a:p>
+            <a:pPr algn="r" indent="0" marL="0">
+              <a:buNone/>
+            </a:pPr>
+            <a:r>
+              <a:rPr lang="en-US" sz="900" dirty="0">
+                <a:solidFill>
+                  <a:srgbClr val="A3A3A3"/>
+                </a:solidFill>
+                <a:latin typeface="Adobe Clean" pitchFamily="34" charset="0"/>
+                <a:ea typeface="Adobe Clean" pitchFamily="34" charset="-122"/>
+                <a:cs typeface="Adobe Clean" pitchFamily="34" charset="-120"/>
+              </a:rPr>
+              <a:t>16</a:t>
+            </a:r>
+            <a:endParaRPr lang="en-US" sz="900" dirty="0"/>
+          </a:p>
+        </p:txBody>
+      </p:sp>
     </p:spTree>
   </p:cSld>
   <p:clrMapOvr>
@@ -10941,6 +11643,84 @@
           </a:p>
         </p:txBody>
       </p:sp>
+      <p:sp>
+        <p:nvSpPr>
+          <p:cNvPr id="19" name="Text 16"/>
+          <p:cNvSpPr txBox="1"/>
+          <p:nvPr/>
+        </p:nvSpPr>
+        <p:spPr>
+          <a:xfrm>
+            <a:off x="457200" y="6473952"/>
+            <a:ext cx="8686800" cy="274320"/>
+          </a:xfrm>
+          <a:prstGeom prst="rect">
+            <a:avLst/>
+          </a:prstGeom>
+          <a:noFill/>
+          <a:ln/>
+        </p:spPr>
+        <p:txBody>
+          <a:bodyPr wrap="square" lIns="0" tIns="0" rIns="0" bIns="0" rtlCol="0" anchor="ctr"/>
+          <a:lstStyle/>
+          <a:p>
+            <a:pPr indent="0" marL="0">
+              <a:buNone/>
+            </a:pPr>
+            <a:r>
+              <a:rPr lang="en-US" sz="900" dirty="0">
+                <a:solidFill>
+                  <a:srgbClr val="8A8A8A"/>
+                </a:solidFill>
+                <a:latin typeface="Adobe Clean" pitchFamily="34" charset="0"/>
+                <a:ea typeface="Adobe Clean" pitchFamily="34" charset="-122"/>
+                <a:cs typeface="Adobe Clean" pitchFamily="34" charset="-120"/>
+              </a:rPr>
+              <a:t>© 2026 Adobe. All Rights Reserved. Adobe Confidential.</a:t>
+            </a:r>
+            <a:endParaRPr lang="en-US" sz="900" dirty="0"/>
+          </a:p>
+        </p:txBody>
+      </p:sp>
+      <p:sp>
+        <p:nvSpPr>
+          <p:cNvPr id="20" name="Text 17"/>
+          <p:cNvSpPr txBox="1"/>
+          <p:nvPr/>
+        </p:nvSpPr>
+        <p:spPr>
+          <a:xfrm>
+            <a:off x="11155680" y="6473952"/>
+            <a:ext cx="640080" cy="274320"/>
+          </a:xfrm>
+          <a:prstGeom prst="rect">
+            <a:avLst/>
+          </a:prstGeom>
+          <a:noFill/>
+          <a:ln/>
+        </p:spPr>
+        <p:txBody>
+          <a:bodyPr wrap="square" lIns="0" tIns="0" rIns="0" bIns="0" rtlCol="0" anchor="ctr"/>
+          <a:lstStyle/>
+          <a:p>
+            <a:pPr algn="r" indent="0" marL="0">
+              <a:buNone/>
+            </a:pPr>
+            <a:r>
+              <a:rPr lang="en-US" sz="900" dirty="0">
+                <a:solidFill>
+                  <a:srgbClr val="8A8A8A"/>
+                </a:solidFill>
+                <a:latin typeface="Adobe Clean" pitchFamily="34" charset="0"/>
+                <a:ea typeface="Adobe Clean" pitchFamily="34" charset="-122"/>
+                <a:cs typeface="Adobe Clean" pitchFamily="34" charset="-120"/>
+              </a:rPr>
+              <a:t>17</a:t>
+            </a:r>
+            <a:endParaRPr lang="en-US" sz="900" dirty="0"/>
+          </a:p>
+        </p:txBody>
+      </p:sp>
     </p:spTree>
   </p:cSld>
   <p:clrMapOvr>
@@ -11316,6 +12096,84 @@
           </a:p>
         </p:txBody>
       </p:sp>
+      <p:sp>
+        <p:nvSpPr>
+          <p:cNvPr id="12" name="Text 9"/>
+          <p:cNvSpPr txBox="1"/>
+          <p:nvPr/>
+        </p:nvSpPr>
+        <p:spPr>
+          <a:xfrm>
+            <a:off x="457200" y="6473952"/>
+            <a:ext cx="8686800" cy="274320"/>
+          </a:xfrm>
+          <a:prstGeom prst="rect">
+            <a:avLst/>
+          </a:prstGeom>
+          <a:noFill/>
+          <a:ln/>
+        </p:spPr>
+        <p:txBody>
+          <a:bodyPr wrap="square" lIns="0" tIns="0" rIns="0" bIns="0" rtlCol="0" anchor="ctr"/>
+          <a:lstStyle/>
+          <a:p>
+            <a:pPr indent="0" marL="0">
+              <a:buNone/>
+            </a:pPr>
+            <a:r>
+              <a:rPr lang="en-US" sz="900" dirty="0">
+                <a:solidFill>
+                  <a:srgbClr val="A3A3A3"/>
+                </a:solidFill>
+                <a:latin typeface="Adobe Clean" pitchFamily="34" charset="0"/>
+                <a:ea typeface="Adobe Clean" pitchFamily="34" charset="-122"/>
+                <a:cs typeface="Adobe Clean" pitchFamily="34" charset="-120"/>
+              </a:rPr>
+              <a:t>© 2026 Adobe. All Rights Reserved. Adobe Confidential.</a:t>
+            </a:r>
+            <a:endParaRPr lang="en-US" sz="900" dirty="0"/>
+          </a:p>
+        </p:txBody>
+      </p:sp>
+      <p:sp>
+        <p:nvSpPr>
+          <p:cNvPr id="13" name="Text 10"/>
+          <p:cNvSpPr txBox="1"/>
+          <p:nvPr/>
+        </p:nvSpPr>
+        <p:spPr>
+          <a:xfrm>
+            <a:off x="11155680" y="6473952"/>
+            <a:ext cx="640080" cy="274320"/>
+          </a:xfrm>
+          <a:prstGeom prst="rect">
+            <a:avLst/>
+          </a:prstGeom>
+          <a:noFill/>
+          <a:ln/>
+        </p:spPr>
+        <p:txBody>
+          <a:bodyPr wrap="square" lIns="0" tIns="0" rIns="0" bIns="0" rtlCol="0" anchor="ctr"/>
+          <a:lstStyle/>
+          <a:p>
+            <a:pPr algn="r" indent="0" marL="0">
+              <a:buNone/>
+            </a:pPr>
+            <a:r>
+              <a:rPr lang="en-US" sz="900" dirty="0">
+                <a:solidFill>
+                  <a:srgbClr val="A3A3A3"/>
+                </a:solidFill>
+                <a:latin typeface="Adobe Clean" pitchFamily="34" charset="0"/>
+                <a:ea typeface="Adobe Clean" pitchFamily="34" charset="-122"/>
+                <a:cs typeface="Adobe Clean" pitchFamily="34" charset="-120"/>
+              </a:rPr>
+              <a:t>18</a:t>
+            </a:r>
+            <a:endParaRPr lang="en-US" sz="900" dirty="0"/>
+          </a:p>
+        </p:txBody>
+      </p:sp>
     </p:spTree>
   </p:cSld>
   <p:clrMapOvr>
@@ -12087,6 +12945,84 @@
           </a:p>
         </p:txBody>
       </p:sp>
+      <p:sp>
+        <p:nvSpPr>
+          <p:cNvPr id="24" name="Text 21"/>
+          <p:cNvSpPr txBox="1"/>
+          <p:nvPr/>
+        </p:nvSpPr>
+        <p:spPr>
+          <a:xfrm>
+            <a:off x="457200" y="6473952"/>
+            <a:ext cx="8686800" cy="274320"/>
+          </a:xfrm>
+          <a:prstGeom prst="rect">
+            <a:avLst/>
+          </a:prstGeom>
+          <a:noFill/>
+          <a:ln/>
+        </p:spPr>
+        <p:txBody>
+          <a:bodyPr wrap="square" lIns="0" tIns="0" rIns="0" bIns="0" rtlCol="0" anchor="ctr"/>
+          <a:lstStyle/>
+          <a:p>
+            <a:pPr indent="0" marL="0">
+              <a:buNone/>
+            </a:pPr>
+            <a:r>
+              <a:rPr lang="en-US" sz="900" dirty="0">
+                <a:solidFill>
+                  <a:srgbClr val="A3A3A3"/>
+                </a:solidFill>
+                <a:latin typeface="Adobe Clean" pitchFamily="34" charset="0"/>
+                <a:ea typeface="Adobe Clean" pitchFamily="34" charset="-122"/>
+                <a:cs typeface="Adobe Clean" pitchFamily="34" charset="-120"/>
+              </a:rPr>
+              <a:t>© 2026 Adobe. All Rights Reserved. Adobe Confidential.</a:t>
+            </a:r>
+            <a:endParaRPr lang="en-US" sz="900" dirty="0"/>
+          </a:p>
+        </p:txBody>
+      </p:sp>
+      <p:sp>
+        <p:nvSpPr>
+          <p:cNvPr id="25" name="Text 22"/>
+          <p:cNvSpPr txBox="1"/>
+          <p:nvPr/>
+        </p:nvSpPr>
+        <p:spPr>
+          <a:xfrm>
+            <a:off x="11155680" y="6473952"/>
+            <a:ext cx="640080" cy="274320"/>
+          </a:xfrm>
+          <a:prstGeom prst="rect">
+            <a:avLst/>
+          </a:prstGeom>
+          <a:noFill/>
+          <a:ln/>
+        </p:spPr>
+        <p:txBody>
+          <a:bodyPr wrap="square" lIns="0" tIns="0" rIns="0" bIns="0" rtlCol="0" anchor="ctr"/>
+          <a:lstStyle/>
+          <a:p>
+            <a:pPr algn="r" indent="0" marL="0">
+              <a:buNone/>
+            </a:pPr>
+            <a:r>
+              <a:rPr lang="en-US" sz="900" dirty="0">
+                <a:solidFill>
+                  <a:srgbClr val="A3A3A3"/>
+                </a:solidFill>
+                <a:latin typeface="Adobe Clean" pitchFamily="34" charset="0"/>
+                <a:ea typeface="Adobe Clean" pitchFamily="34" charset="-122"/>
+                <a:cs typeface="Adobe Clean" pitchFamily="34" charset="-120"/>
+              </a:rPr>
+              <a:t>19</a:t>
+            </a:r>
+            <a:endParaRPr lang="en-US" sz="900" dirty="0"/>
+          </a:p>
+        </p:txBody>
+      </p:sp>
     </p:spTree>
   </p:cSld>
   <p:clrMapOvr>
@@ -12152,7 +13088,7 @@
                 <a:ea typeface="Adobe Clean" pitchFamily="34" charset="-122"/>
                 <a:cs typeface="Adobe Clean" pitchFamily="34" charset="-120"/>
               </a:rPr>
-              <a:t>WHY THIS SESSION</a:t>
+              <a:t>AIM OF THIS SESSION</a:t>
             </a:r>
             <a:endParaRPr lang="en-US" sz="1250" dirty="0"/>
           </a:p>
@@ -12191,7 +13127,7 @@
                 <a:ea typeface="Adobe Clean" pitchFamily="34" charset="-122"/>
                 <a:cs typeface="Adobe Clean" pitchFamily="34" charset="-120"/>
               </a:rPr>
-              <a:t>We know AEP. Today we look one step upstream.</a:t>
+              <a:t>Understand the flow — and route cases with confidence</a:t>
             </a:r>
             <a:endParaRPr lang="en-US" sz="3200" dirty="0"/>
           </a:p>
@@ -12199,56 +13135,95 @@
       </p:sp>
       <p:sp>
         <p:nvSpPr>
-          <p:cNvPr id="4" name="Shape 2"/>
+          <p:cNvPr id="4" name="Text 2"/>
+          <p:cNvSpPr txBox="1"/>
+          <p:nvPr/>
+        </p:nvSpPr>
+        <p:spPr>
+          <a:xfrm>
+            <a:off x="548640" y="1371600"/>
+            <a:ext cx="11091672" cy="640080"/>
+          </a:xfrm>
+          <a:prstGeom prst="rect">
+            <a:avLst/>
+          </a:prstGeom>
+          <a:noFill/>
+          <a:ln/>
+        </p:spPr>
+        <p:txBody>
+          <a:bodyPr wrap="square" lIns="0" tIns="0" rIns="0" bIns="0" rtlCol="0" anchor="ctr"/>
+          <a:lstStyle/>
+          <a:p>
+            <a:pPr indent="0" marL="0">
+              <a:buNone/>
+            </a:pPr>
+            <a:r>
+              <a:rPr lang="en-US" sz="1400" dirty="0">
+                <a:solidFill>
+                  <a:srgbClr val="6B6B6B"/>
+                </a:solidFill>
+                <a:latin typeface="Adobe Clean" pitchFamily="34" charset="0"/>
+                <a:ea typeface="Adobe Clean" pitchFamily="34" charset="-122"/>
+                <a:cs typeface="Adobe Clean" pitchFamily="34" charset="-120"/>
+              </a:rPr>
+              <a:t>We are an AEP support team. We do not build or debug a customer’s Data Collection setup — but we must understand how website data reaches AEP so we can investigate, guide the customer, and route the case to the right team.</a:t>
+            </a:r>
+            <a:endParaRPr lang="en-US" sz="1400" dirty="0"/>
+          </a:p>
+        </p:txBody>
+      </p:sp>
+      <p:sp>
+        <p:nvSpPr>
+          <p:cNvPr id="5" name="Shape 3"/>
           <p:cNvSpPr/>
           <p:nvPr/>
         </p:nvSpPr>
         <p:spPr>
           <a:xfrm>
-            <a:off x="548640" y="1737360"/>
-            <a:ext cx="11091672" cy="1234440"/>
+            <a:off x="548640" y="2148840"/>
+            <a:ext cx="5362956" cy="3200400"/>
           </a:xfrm>
           <a:prstGeom prst="roundRect">
             <a:avLst>
-              <a:gd name="adj" fmla="val 5926"/>
+              <a:gd name="adj" fmla="val 2571"/>
             </a:avLst>
           </a:prstGeom>
           <a:solidFill>
-            <a:srgbClr val="FDECEA"/>
+            <a:srgbClr val="F7F7F7"/>
           </a:solidFill>
           <a:ln/>
         </p:spPr>
       </p:sp>
       <p:sp>
         <p:nvSpPr>
-          <p:cNvPr id="5" name="Shape 3"/>
+          <p:cNvPr id="6" name="Shape 4"/>
           <p:cNvSpPr/>
           <p:nvPr/>
         </p:nvSpPr>
         <p:spPr>
           <a:xfrm>
-            <a:off x="822960" y="2039112"/>
-            <a:ext cx="640080" cy="640080"/>
+            <a:off x="822960" y="2423160"/>
+            <a:ext cx="457200" cy="457200"/>
           </a:xfrm>
           <a:prstGeom prst="ellipse">
             <a:avLst/>
           </a:prstGeom>
           <a:solidFill>
-            <a:srgbClr val="EB1000"/>
+            <a:srgbClr val="0AA35B"/>
           </a:solidFill>
           <a:ln/>
         </p:spPr>
       </p:sp>
       <p:sp>
         <p:nvSpPr>
-          <p:cNvPr id="6" name="Text 4"/>
-          <p:cNvSpPr txBox="1"/>
-          <p:nvPr/>
-        </p:nvSpPr>
-        <p:spPr>
-          <a:xfrm>
-            <a:off x="822960" y="2039112"/>
-            <a:ext cx="640080" cy="640080"/>
+          <p:cNvPr id="7" name="Text 5"/>
+          <p:cNvSpPr txBox="1"/>
+          <p:nvPr/>
+        </p:nvSpPr>
+        <p:spPr>
+          <a:xfrm>
+            <a:off x="822960" y="2423160"/>
+            <a:ext cx="457200" cy="457200"/>
           </a:xfrm>
           <a:prstGeom prst="rect">
             <a:avLst/>
@@ -12264,27 +13239,27 @@
               <a:buNone/>
             </a:pPr>
             <a:r>
-              <a:rPr lang="en-US" sz="2200" dirty="0">
+              <a:rPr lang="en-US" sz="1800" dirty="0">
                 <a:solidFill>
                   <a:srgbClr val="000000"/>
                 </a:solidFill>
               </a:rPr>
-              <a:t>🎯</a:t>
-            </a:r>
-            <a:endParaRPr lang="en-US" sz="2200" dirty="0"/>
-          </a:p>
-        </p:txBody>
-      </p:sp>
-      <p:sp>
-        <p:nvSpPr>
-          <p:cNvPr id="7" name="Text 5"/>
-          <p:cNvSpPr txBox="1"/>
-          <p:nvPr/>
-        </p:nvSpPr>
-        <p:spPr>
-          <a:xfrm>
-            <a:off x="1737360" y="1920240"/>
-            <a:ext cx="2926080" cy="822960"/>
+              <a:t>🔎</a:t>
+            </a:r>
+            <a:endParaRPr lang="en-US" sz="1800" dirty="0"/>
+          </a:p>
+        </p:txBody>
+      </p:sp>
+      <p:sp>
+        <p:nvSpPr>
+          <p:cNvPr id="8" name="Text 6"/>
+          <p:cNvSpPr txBox="1"/>
+          <p:nvPr/>
+        </p:nvSpPr>
+        <p:spPr>
+          <a:xfrm>
+            <a:off x="1417320" y="2441448"/>
+            <a:ext cx="4265676" cy="457200"/>
           </a:xfrm>
           <a:prstGeom prst="rect">
             <a:avLst/>
@@ -12300,7 +13275,7 @@
               <a:buNone/>
             </a:pPr>
             <a:r>
-              <a:rPr lang="en-US" sz="2000" b="1" dirty="0">
+              <a:rPr lang="en-US" sz="1550" b="1" dirty="0">
                 <a:solidFill>
                   <a:srgbClr val="1F1F1F"/>
                 </a:solidFill>
@@ -12308,103 +13283,212 @@
                 <a:ea typeface="Adobe Clean" pitchFamily="34" charset="-122"/>
                 <a:cs typeface="Adobe Clean" pitchFamily="34" charset="-120"/>
               </a:rPr>
-              <a:t>The goal</a:t>
-            </a:r>
-            <a:endParaRPr lang="en-US" sz="2000" dirty="0"/>
-          </a:p>
-        </p:txBody>
-      </p:sp>
-      <p:sp>
-        <p:nvSpPr>
-          <p:cNvPr id="8" name="Text 6"/>
-          <p:cNvSpPr txBox="1"/>
-          <p:nvPr/>
-        </p:nvSpPr>
-        <p:spPr>
-          <a:xfrm>
-            <a:off x="4754880" y="1920240"/>
-            <a:ext cx="6519672" cy="868680"/>
-          </a:xfrm>
-          <a:prstGeom prst="rect">
-            <a:avLst/>
-          </a:prstGeom>
-          <a:noFill/>
-          <a:ln/>
-        </p:spPr>
-        <p:txBody>
-          <a:bodyPr wrap="square" lIns="0" tIns="0" rIns="0" bIns="0" rtlCol="0" anchor="ctr"/>
-          <a:lstStyle/>
-          <a:p>
-            <a:pPr indent="0" marL="0">
-              <a:buNone/>
-            </a:pPr>
-            <a:r>
-              <a:rPr lang="en-US" sz="1500" dirty="0">
-                <a:solidFill>
-                  <a:srgbClr val="6B6B6B"/>
-                </a:solidFill>
-                <a:latin typeface="Adobe Clean" pitchFamily="34" charset="0"/>
-                <a:ea typeface="Adobe Clean" pitchFamily="34" charset="-122"/>
-                <a:cs typeface="Adobe Clean" pitchFamily="34" charset="-120"/>
-              </a:rPr>
-              <a:t>See how website data is collected and shaped before it ever reaches AEP.</a:t>
-            </a:r>
-            <a:endParaRPr lang="en-US" sz="1500" dirty="0"/>
-          </a:p>
-        </p:txBody>
-      </p:sp>
-      <p:sp>
-        <p:nvSpPr>
-          <p:cNvPr id="9" name="Shape 7"/>
+              <a:t>What you’ll be able to reason about</a:t>
+            </a:r>
+            <a:endParaRPr lang="en-US" sz="1550" dirty="0"/>
+          </a:p>
+        </p:txBody>
+      </p:sp>
+      <p:sp>
+        <p:nvSpPr>
+          <p:cNvPr id="9" name="Text 7"/>
+          <p:cNvSpPr txBox="1"/>
+          <p:nvPr/>
+        </p:nvSpPr>
+        <p:spPr>
+          <a:xfrm>
+            <a:off x="914400" y="3063240"/>
+            <a:ext cx="4631436" cy="2103120"/>
+          </a:xfrm>
+          <a:prstGeom prst="rect">
+            <a:avLst/>
+          </a:prstGeom>
+          <a:noFill/>
+          <a:ln/>
+        </p:spPr>
+        <p:txBody>
+          <a:bodyPr wrap="square" lIns="0" tIns="0" rIns="0" bIns="0" rtlCol="0" anchor="ctr"/>
+          <a:lstStyle/>
+          <a:p>
+            <a:pPr marL="342900" indent="-342900">
+              <a:spcAft>
+                <a:spcPts val="700"/>
+              </a:spcAft>
+              <a:buSzPct val="100000"/>
+              <a:buChar char="•"/>
+            </a:pPr>
+            <a:r>
+              <a:rPr lang="en-US" sz="1300" dirty="0">
+                <a:solidFill>
+                  <a:srgbClr val="1F1F1F"/>
+                </a:solidFill>
+                <a:latin typeface="Adobe Clean" pitchFamily="34" charset="0"/>
+                <a:ea typeface="Adobe Clean" pitchFamily="34" charset="-122"/>
+                <a:cs typeface="Adobe Clean" pitchFamily="34" charset="-120"/>
+              </a:rPr>
+              <a:t>Web SDK: a hit is missing, or some data isn’t ingested</a:t>
+            </a:r>
+            <a:endParaRPr lang="en-US" sz="1300" dirty="0"/>
+          </a:p>
+          <a:p>
+            <a:pPr marL="342900" indent="-342900">
+              <a:spcAft>
+                <a:spcPts val="700"/>
+              </a:spcAft>
+              <a:buSzPct val="100000"/>
+              <a:buChar char="•"/>
+            </a:pPr>
+            <a:r>
+              <a:rPr lang="en-US" sz="1300" dirty="0">
+                <a:solidFill>
+                  <a:srgbClr val="1F1F1F"/>
+                </a:solidFill>
+                <a:latin typeface="Adobe Clean" pitchFamily="34" charset="0"/>
+                <a:ea typeface="Adobe Clean" pitchFamily="34" charset="-122"/>
+                <a:cs typeface="Adobe Clean" pitchFamily="34" charset="-120"/>
+              </a:rPr>
+              <a:t>Mobile SDK: how the data flows in</a:t>
+            </a:r>
+            <a:endParaRPr lang="en-US" sz="1300" dirty="0"/>
+          </a:p>
+          <a:p>
+            <a:pPr marL="342900" indent="-342900">
+              <a:spcAft>
+                <a:spcPts val="700"/>
+              </a:spcAft>
+              <a:buSzPct val="100000"/>
+              <a:buChar char="•"/>
+            </a:pPr>
+            <a:r>
+              <a:rPr lang="en-US" sz="1300" dirty="0">
+                <a:solidFill>
+                  <a:srgbClr val="1F1F1F"/>
+                </a:solidFill>
+                <a:latin typeface="Adobe Clean" pitchFamily="34" charset="0"/>
+                <a:ea typeface="Adobe Clean" pitchFamily="34" charset="-122"/>
+                <a:cs typeface="Adobe Clean" pitchFamily="34" charset="-120"/>
+              </a:rPr>
+              <a:t>Using Adobe Assurance to trace an event</a:t>
+            </a:r>
+            <a:endParaRPr lang="en-US" sz="1300" dirty="0"/>
+          </a:p>
+          <a:p>
+            <a:pPr marL="342900" indent="-342900">
+              <a:spcAft>
+                <a:spcPts val="700"/>
+              </a:spcAft>
+              <a:buSzPct val="100000"/>
+              <a:buChar char="•"/>
+            </a:pPr>
+            <a:r>
+              <a:rPr lang="en-US" sz="1300" dirty="0">
+                <a:solidFill>
+                  <a:srgbClr val="1F1F1F"/>
+                </a:solidFill>
+                <a:latin typeface="Adobe Clean" pitchFamily="34" charset="0"/>
+                <a:ea typeface="Adobe Clean" pitchFamily="34" charset="-122"/>
+                <a:cs typeface="Adobe Clean" pitchFamily="34" charset="-120"/>
+              </a:rPr>
+              <a:t>Reading a failed batch / ingestion error</a:t>
+            </a:r>
+            <a:endParaRPr lang="en-US" sz="1300" dirty="0"/>
+          </a:p>
+          <a:p>
+            <a:pPr marL="342900" indent="-342900">
+              <a:spcAft>
+                <a:spcPts val="700"/>
+              </a:spcAft>
+              <a:buSzPct val="100000"/>
+              <a:buChar char="•"/>
+            </a:pPr>
+            <a:r>
+              <a:rPr lang="en-US" sz="1300" dirty="0">
+                <a:solidFill>
+                  <a:srgbClr val="1F1F1F"/>
+                </a:solidFill>
+                <a:latin typeface="Adobe Clean" pitchFamily="34" charset="0"/>
+                <a:ea typeface="Adobe Clean" pitchFamily="34" charset="-122"/>
+                <a:cs typeface="Adobe Clean" pitchFamily="34" charset="-120"/>
+              </a:rPr>
+              <a:t>Guiding the customer to the right next step</a:t>
+            </a:r>
+            <a:endParaRPr lang="en-US" sz="1300" dirty="0"/>
+          </a:p>
+          <a:p>
+            <a:pPr marL="342900" indent="-342900">
+              <a:spcAft>
+                <a:spcPts val="700"/>
+              </a:spcAft>
+              <a:buSzPct val="100000"/>
+              <a:buChar char="•"/>
+            </a:pPr>
+            <a:r>
+              <a:rPr lang="en-US" sz="1300" dirty="0">
+                <a:solidFill>
+                  <a:srgbClr val="1F1F1F"/>
+                </a:solidFill>
+                <a:latin typeface="Adobe Clean" pitchFamily="34" charset="0"/>
+                <a:ea typeface="Adobe Clean" pitchFamily="34" charset="-122"/>
+                <a:cs typeface="Adobe Clean" pitchFamily="34" charset="-120"/>
+              </a:rPr>
+              <a:t>Deciding who owns it: us, Data Collection, or Analytics</a:t>
+            </a:r>
+            <a:endParaRPr lang="en-US" sz="1300" dirty="0"/>
+          </a:p>
+        </p:txBody>
+      </p:sp>
+      <p:sp>
+        <p:nvSpPr>
+          <p:cNvPr id="10" name="Shape 8"/>
           <p:cNvSpPr/>
           <p:nvPr/>
         </p:nvSpPr>
         <p:spPr>
           <a:xfrm>
-            <a:off x="548640" y="3154680"/>
-            <a:ext cx="11091672" cy="1234440"/>
+            <a:off x="6277356" y="2148840"/>
+            <a:ext cx="5362956" cy="3200400"/>
           </a:xfrm>
           <a:prstGeom prst="roundRect">
             <a:avLst>
-              <a:gd name="adj" fmla="val 5926"/>
+              <a:gd name="adj" fmla="val 2571"/>
             </a:avLst>
           </a:prstGeom>
           <a:solidFill>
-            <a:srgbClr val="FDECEA"/>
+            <a:srgbClr val="F7F7F7"/>
           </a:solidFill>
           <a:ln/>
         </p:spPr>
       </p:sp>
       <p:sp>
         <p:nvSpPr>
-          <p:cNvPr id="10" name="Shape 8"/>
+          <p:cNvPr id="11" name="Shape 9"/>
           <p:cNvSpPr/>
           <p:nvPr/>
         </p:nvSpPr>
         <p:spPr>
           <a:xfrm>
-            <a:off x="822960" y="3456432"/>
-            <a:ext cx="640080" cy="640080"/>
+            <a:off x="6551676" y="2423160"/>
+            <a:ext cx="457200" cy="457200"/>
           </a:xfrm>
           <a:prstGeom prst="ellipse">
             <a:avLst/>
           </a:prstGeom>
           <a:solidFill>
-            <a:srgbClr val="EB1000"/>
+            <a:srgbClr val="3A63F9"/>
           </a:solidFill>
           <a:ln/>
         </p:spPr>
       </p:sp>
       <p:sp>
         <p:nvSpPr>
-          <p:cNvPr id="11" name="Text 9"/>
-          <p:cNvSpPr txBox="1"/>
-          <p:nvPr/>
-        </p:nvSpPr>
-        <p:spPr>
-          <a:xfrm>
-            <a:off x="822960" y="3456432"/>
-            <a:ext cx="640080" cy="640080"/>
+          <p:cNvPr id="12" name="Text 10"/>
+          <p:cNvSpPr txBox="1"/>
+          <p:nvPr/>
+        </p:nvSpPr>
+        <p:spPr>
+          <a:xfrm>
+            <a:off x="6551676" y="2423160"/>
+            <a:ext cx="457200" cy="457200"/>
           </a:xfrm>
           <a:prstGeom prst="rect">
             <a:avLst/>
@@ -12420,27 +13504,27 @@
               <a:buNone/>
             </a:pPr>
             <a:r>
-              <a:rPr lang="en-US" sz="2200" dirty="0">
+              <a:rPr lang="en-US" sz="1800" dirty="0">
                 <a:solidFill>
                   <a:srgbClr val="000000"/>
                 </a:solidFill>
               </a:rPr>
-              <a:t>🧩</a:t>
-            </a:r>
-            <a:endParaRPr lang="en-US" sz="2200" dirty="0"/>
-          </a:p>
-        </p:txBody>
-      </p:sp>
-      <p:sp>
-        <p:nvSpPr>
-          <p:cNvPr id="12" name="Text 10"/>
-          <p:cNvSpPr txBox="1"/>
-          <p:nvPr/>
-        </p:nvSpPr>
-        <p:spPr>
-          <a:xfrm>
-            <a:off x="1737360" y="3337560"/>
-            <a:ext cx="2926080" cy="822960"/>
+              <a:t>🎁</a:t>
+            </a:r>
+            <a:endParaRPr lang="en-US" sz="1800" dirty="0"/>
+          </a:p>
+        </p:txBody>
+      </p:sp>
+      <p:sp>
+        <p:nvSpPr>
+          <p:cNvPr id="13" name="Text 11"/>
+          <p:cNvSpPr txBox="1"/>
+          <p:nvPr/>
+        </p:nvSpPr>
+        <p:spPr>
+          <a:xfrm>
+            <a:off x="7146036" y="2441448"/>
+            <a:ext cx="4265676" cy="457200"/>
           </a:xfrm>
           <a:prstGeom prst="rect">
             <a:avLst/>
@@ -12456,7 +13540,7 @@
               <a:buNone/>
             </a:pPr>
             <a:r>
-              <a:rPr lang="en-US" sz="2000" b="1" dirty="0">
+              <a:rPr lang="en-US" sz="1550" b="1" dirty="0">
                 <a:solidFill>
                   <a:srgbClr val="1F1F1F"/>
                 </a:solidFill>
@@ -12464,22 +13548,149 @@
                 <a:ea typeface="Adobe Clean" pitchFamily="34" charset="-122"/>
                 <a:cs typeface="Adobe Clean" pitchFamily="34" charset="-120"/>
               </a:rPr>
-              <a:t>The gap</a:t>
-            </a:r>
-            <a:endParaRPr lang="en-US" sz="2000" dirty="0"/>
-          </a:p>
-        </p:txBody>
-      </p:sp>
-      <p:sp>
-        <p:nvSpPr>
-          <p:cNvPr id="13" name="Text 11"/>
-          <p:cNvSpPr txBox="1"/>
-          <p:nvPr/>
-        </p:nvSpPr>
-        <p:spPr>
-          <a:xfrm>
-            <a:off x="4754880" y="3337560"/>
-            <a:ext cx="6519672" cy="868680"/>
+              <a:t>What this project gives you</a:t>
+            </a:r>
+            <a:endParaRPr lang="en-US" sz="1550" dirty="0"/>
+          </a:p>
+        </p:txBody>
+      </p:sp>
+      <p:sp>
+        <p:nvSpPr>
+          <p:cNvPr id="14" name="Text 12"/>
+          <p:cNvSpPr txBox="1"/>
+          <p:nvPr/>
+        </p:nvSpPr>
+        <p:spPr>
+          <a:xfrm>
+            <a:off x="6643116" y="3063240"/>
+            <a:ext cx="4631436" cy="2103120"/>
+          </a:xfrm>
+          <a:prstGeom prst="rect">
+            <a:avLst/>
+          </a:prstGeom>
+          <a:noFill/>
+          <a:ln/>
+        </p:spPr>
+        <p:txBody>
+          <a:bodyPr wrap="square" lIns="0" tIns="0" rIns="0" bIns="0" rtlCol="0" anchor="ctr"/>
+          <a:lstStyle/>
+          <a:p>
+            <a:pPr marL="342900" indent="-342900">
+              <a:spcAft>
+                <a:spcPts val="700"/>
+              </a:spcAft>
+              <a:buSzPct val="100000"/>
+              <a:buChar char="•"/>
+            </a:pPr>
+            <a:r>
+              <a:rPr lang="en-US" sz="1300" dirty="0">
+                <a:solidFill>
+                  <a:srgbClr val="1F1F1F"/>
+                </a:solidFill>
+                <a:latin typeface="Adobe Clean" pitchFamily="34" charset="0"/>
+                <a:ea typeface="Adobe Clean" pitchFamily="34" charset="-122"/>
+                <a:cs typeface="Adobe Clean" pitchFamily="34" charset="-120"/>
+              </a:rPr>
+              <a:t>Set up Data Collection hands-on (schema, datastream, rules)</a:t>
+            </a:r>
+            <a:endParaRPr lang="en-US" sz="1300" dirty="0"/>
+          </a:p>
+          <a:p>
+            <a:pPr marL="342900" indent="-342900">
+              <a:spcAft>
+                <a:spcPts val="700"/>
+              </a:spcAft>
+              <a:buSzPct val="100000"/>
+              <a:buChar char="•"/>
+            </a:pPr>
+            <a:r>
+              <a:rPr lang="en-US" sz="1300" dirty="0">
+                <a:solidFill>
+                  <a:srgbClr val="1F1F1F"/>
+                </a:solidFill>
+                <a:latin typeface="Adobe Clean" pitchFamily="34" charset="0"/>
+                <a:ea typeface="Adobe Clean" pitchFamily="34" charset="-122"/>
+                <a:cs typeface="Adobe Clean" pitchFamily="34" charset="-120"/>
+              </a:rPr>
+              <a:t>Send streaming data into a real-time AEP profile</a:t>
+            </a:r>
+            <a:endParaRPr lang="en-US" sz="1300" dirty="0"/>
+          </a:p>
+          <a:p>
+            <a:pPr marL="342900" indent="-342900">
+              <a:spcAft>
+                <a:spcPts val="700"/>
+              </a:spcAft>
+              <a:buSzPct val="100000"/>
+              <a:buChar char="•"/>
+            </a:pPr>
+            <a:r>
+              <a:rPr lang="en-US" sz="1300" dirty="0">
+                <a:solidFill>
+                  <a:srgbClr val="1F1F1F"/>
+                </a:solidFill>
+                <a:latin typeface="Adobe Clean" pitchFamily="34" charset="0"/>
+                <a:ea typeface="Adobe Clean" pitchFamily="34" charset="-122"/>
+                <a:cs typeface="Adobe Clean" pitchFamily="34" charset="-120"/>
+              </a:rPr>
+              <a:t>See website data ingested into AEP (and other stores)</a:t>
+            </a:r>
+            <a:endParaRPr lang="en-US" sz="1300" dirty="0"/>
+          </a:p>
+          <a:p>
+            <a:pPr marL="342900" indent="-342900">
+              <a:spcAft>
+                <a:spcPts val="700"/>
+              </a:spcAft>
+              <a:buSzPct val="100000"/>
+              <a:buChar char="•"/>
+            </a:pPr>
+            <a:r>
+              <a:rPr lang="en-US" sz="1300" dirty="0">
+                <a:solidFill>
+                  <a:srgbClr val="1F1F1F"/>
+                </a:solidFill>
+                <a:latin typeface="Adobe Clean" pitchFamily="34" charset="0"/>
+                <a:ea typeface="Adobe Clean" pitchFamily="34" charset="-122"/>
+                <a:cs typeface="Adobe Clean" pitchFamily="34" charset="-120"/>
+              </a:rPr>
+              <a:t>A practical, end-to-end mental model of the pipeline</a:t>
+            </a:r>
+            <a:endParaRPr lang="en-US" sz="1300" dirty="0"/>
+          </a:p>
+          <a:p>
+            <a:pPr marL="342900" indent="-342900">
+              <a:spcAft>
+                <a:spcPts val="700"/>
+              </a:spcAft>
+              <a:buSzPct val="100000"/>
+              <a:buChar char="•"/>
+            </a:pPr>
+            <a:r>
+              <a:rPr lang="en-US" sz="1300" dirty="0">
+                <a:solidFill>
+                  <a:srgbClr val="1F1F1F"/>
+                </a:solidFill>
+                <a:latin typeface="Adobe Clean" pitchFamily="34" charset="0"/>
+                <a:ea typeface="Adobe Clean" pitchFamily="34" charset="-122"/>
+                <a:cs typeface="Adobe Clean" pitchFamily="34" charset="-120"/>
+              </a:rPr>
+              <a:t>Confidence to investigate and route a case correctly</a:t>
+            </a:r>
+            <a:endParaRPr lang="en-US" sz="1300" dirty="0"/>
+          </a:p>
+        </p:txBody>
+      </p:sp>
+      <p:sp>
+        <p:nvSpPr>
+          <p:cNvPr id="15" name="Text 13"/>
+          <p:cNvSpPr txBox="1"/>
+          <p:nvPr/>
+        </p:nvSpPr>
+        <p:spPr>
+          <a:xfrm>
+            <a:off x="548640" y="5623560"/>
+            <a:ext cx="11091672" cy="548640"/>
           </a:xfrm>
           <a:prstGeom prst="rect">
             <a:avLst/>
@@ -12495,7 +13706,21 @@
               <a:buNone/>
             </a:pPr>
             <a:r>
-              <a:rPr lang="en-US" sz="1500" dirty="0">
+              <a:rPr lang="en-US" sz="1250" b="1" dirty="0">
+                <a:solidFill>
+                  <a:srgbClr val="B10C00"/>
+                </a:solidFill>
+                <a:latin typeface="Adobe Clean" pitchFamily="34" charset="0"/>
+                <a:ea typeface="Adobe Clean" pitchFamily="34" charset="-122"/>
+                <a:cs typeface="Adobe Clean" pitchFamily="34" charset="-120"/>
+              </a:rPr>
+              <a:t>Scope:  </a:t>
+            </a:r>
+            <a:pPr indent="0" marL="0">
+              <a:buNone/>
+            </a:pPr>
+            <a:r>
+              <a:rPr lang="en-US" sz="1250" dirty="0">
                 <a:solidFill>
                   <a:srgbClr val="6B6B6B"/>
                 </a:solidFill>
@@ -12503,100 +13728,22 @@
                 <a:ea typeface="Adobe Clean" pitchFamily="34" charset="-122"/>
                 <a:cs typeface="Adobe Clean" pitchFamily="34" charset="-120"/>
               </a:rPr>
-              <a:t>Support lives in AEP, but most "data is missing" issues start in Data Collection.</a:t>
-            </a:r>
-            <a:endParaRPr lang="en-US" sz="1500" dirty="0"/>
-          </a:p>
-        </p:txBody>
-      </p:sp>
-      <p:sp>
-        <p:nvSpPr>
-          <p:cNvPr id="14" name="Shape 12"/>
-          <p:cNvSpPr/>
-          <p:nvPr/>
-        </p:nvSpPr>
-        <p:spPr>
-          <a:xfrm>
-            <a:off x="548640" y="4572000"/>
-            <a:ext cx="11091672" cy="1234440"/>
-          </a:xfrm>
-          <a:prstGeom prst="roundRect">
-            <a:avLst>
-              <a:gd name="adj" fmla="val 5926"/>
-            </a:avLst>
-          </a:prstGeom>
-          <a:solidFill>
-            <a:srgbClr val="FDECEA"/>
-          </a:solidFill>
-          <a:ln/>
-        </p:spPr>
-      </p:sp>
-      <p:sp>
-        <p:nvSpPr>
-          <p:cNvPr id="15" name="Shape 13"/>
-          <p:cNvSpPr/>
-          <p:nvPr/>
-        </p:nvSpPr>
-        <p:spPr>
-          <a:xfrm>
-            <a:off x="822960" y="4873752"/>
-            <a:ext cx="640080" cy="640080"/>
-          </a:xfrm>
-          <a:prstGeom prst="ellipse">
-            <a:avLst/>
-          </a:prstGeom>
-          <a:solidFill>
-            <a:srgbClr val="EB1000"/>
-          </a:solidFill>
-          <a:ln/>
-        </p:spPr>
-      </p:sp>
-      <p:sp>
-        <p:nvSpPr>
-          <p:cNvPr id="16" name="Text 14"/>
-          <p:cNvSpPr txBox="1"/>
-          <p:nvPr/>
-        </p:nvSpPr>
-        <p:spPr>
-          <a:xfrm>
-            <a:off x="822960" y="4873752"/>
-            <a:ext cx="640080" cy="640080"/>
-          </a:xfrm>
-          <a:prstGeom prst="rect">
-            <a:avLst/>
-          </a:prstGeom>
-          <a:noFill/>
-          <a:ln/>
-        </p:spPr>
-        <p:txBody>
-          <a:bodyPr wrap="square" lIns="0" tIns="0" rIns="0" bIns="0" rtlCol="0" anchor="ctr"/>
-          <a:lstStyle/>
-          <a:p>
-            <a:pPr algn="ctr" indent="0" marL="0">
-              <a:buNone/>
-            </a:pPr>
-            <a:r>
-              <a:rPr lang="en-US" sz="2200" dirty="0">
-                <a:solidFill>
-                  <a:srgbClr val="000000"/>
-                </a:solidFill>
-              </a:rPr>
-              <a:t>🛠️</a:t>
-            </a:r>
-            <a:endParaRPr lang="en-US" sz="2200" dirty="0"/>
-          </a:p>
-        </p:txBody>
-      </p:sp>
-      <p:sp>
-        <p:nvSpPr>
-          <p:cNvPr id="17" name="Text 15"/>
-          <p:cNvSpPr txBox="1"/>
-          <p:nvPr/>
-        </p:nvSpPr>
-        <p:spPr>
-          <a:xfrm>
-            <a:off x="1737360" y="4754880"/>
-            <a:ext cx="2926080" cy="822960"/>
+              <a:t>debugging a customer’s Data Collection implementation sits with the Data Collection / Analytics team. Our job is to understand the flow and route the case to the right owner.</a:t>
+            </a:r>
+            <a:endParaRPr lang="en-US" sz="1250" dirty="0"/>
+          </a:p>
+        </p:txBody>
+      </p:sp>
+      <p:sp>
+        <p:nvSpPr>
+          <p:cNvPr id="17" name="Text 14"/>
+          <p:cNvSpPr txBox="1"/>
+          <p:nvPr/>
+        </p:nvSpPr>
+        <p:spPr>
+          <a:xfrm>
+            <a:off x="457200" y="6473952"/>
+            <a:ext cx="8686800" cy="274320"/>
           </a:xfrm>
           <a:prstGeom prst="rect">
             <a:avLst/>
@@ -12612,56 +13759,56 @@
               <a:buNone/>
             </a:pPr>
             <a:r>
-              <a:rPr lang="en-US" sz="2000" b="1" dirty="0">
-                <a:solidFill>
-                  <a:srgbClr val="1F1F1F"/>
-                </a:solidFill>
-                <a:latin typeface="Adobe Clean" pitchFamily="34" charset="0"/>
-                <a:ea typeface="Adobe Clean" pitchFamily="34" charset="-122"/>
-                <a:cs typeface="Adobe Clean" pitchFamily="34" charset="-120"/>
-              </a:rPr>
-              <a:t>The payoff</a:t>
-            </a:r>
-            <a:endParaRPr lang="en-US" sz="2000" dirty="0"/>
-          </a:p>
-        </p:txBody>
-      </p:sp>
-      <p:sp>
-        <p:nvSpPr>
-          <p:cNvPr id="18" name="Text 16"/>
-          <p:cNvSpPr txBox="1"/>
-          <p:nvPr/>
-        </p:nvSpPr>
-        <p:spPr>
-          <a:xfrm>
-            <a:off x="4754880" y="4754880"/>
-            <a:ext cx="6519672" cy="868680"/>
-          </a:xfrm>
-          <a:prstGeom prst="rect">
-            <a:avLst/>
-          </a:prstGeom>
-          <a:noFill/>
-          <a:ln/>
-        </p:spPr>
-        <p:txBody>
-          <a:bodyPr wrap="square" lIns="0" tIns="0" rIns="0" bIns="0" rtlCol="0" anchor="ctr"/>
-          <a:lstStyle/>
-          <a:p>
-            <a:pPr indent="0" marL="0">
-              <a:buNone/>
-            </a:pPr>
-            <a:r>
-              <a:rPr lang="en-US" sz="1500" dirty="0">
-                <a:solidFill>
-                  <a:srgbClr val="6B6B6B"/>
-                </a:solidFill>
-                <a:latin typeface="Adobe Clean" pitchFamily="34" charset="0"/>
-                <a:ea typeface="Adobe Clean" pitchFamily="34" charset="-122"/>
-                <a:cs typeface="Adobe Clean" pitchFamily="34" charset="-120"/>
-              </a:rPr>
-              <a:t>Know where to look — data layer, rules, data elements, datastream — when data is wrong or absent.</a:t>
-            </a:r>
-            <a:endParaRPr lang="en-US" sz="1500" dirty="0"/>
+              <a:rPr lang="en-US" sz="900" dirty="0">
+                <a:solidFill>
+                  <a:srgbClr val="A3A3A3"/>
+                </a:solidFill>
+                <a:latin typeface="Adobe Clean" pitchFamily="34" charset="0"/>
+                <a:ea typeface="Adobe Clean" pitchFamily="34" charset="-122"/>
+                <a:cs typeface="Adobe Clean" pitchFamily="34" charset="-120"/>
+              </a:rPr>
+              <a:t>© 2026 Adobe. All Rights Reserved. Adobe Confidential.</a:t>
+            </a:r>
+            <a:endParaRPr lang="en-US" sz="900" dirty="0"/>
+          </a:p>
+        </p:txBody>
+      </p:sp>
+      <p:sp>
+        <p:nvSpPr>
+          <p:cNvPr id="18" name="Text 15"/>
+          <p:cNvSpPr txBox="1"/>
+          <p:nvPr/>
+        </p:nvSpPr>
+        <p:spPr>
+          <a:xfrm>
+            <a:off x="11155680" y="6473952"/>
+            <a:ext cx="640080" cy="274320"/>
+          </a:xfrm>
+          <a:prstGeom prst="rect">
+            <a:avLst/>
+          </a:prstGeom>
+          <a:noFill/>
+          <a:ln/>
+        </p:spPr>
+        <p:txBody>
+          <a:bodyPr wrap="square" lIns="0" tIns="0" rIns="0" bIns="0" rtlCol="0" anchor="ctr"/>
+          <a:lstStyle/>
+          <a:p>
+            <a:pPr algn="r" indent="0" marL="0">
+              <a:buNone/>
+            </a:pPr>
+            <a:r>
+              <a:rPr lang="en-US" sz="900" dirty="0">
+                <a:solidFill>
+                  <a:srgbClr val="A3A3A3"/>
+                </a:solidFill>
+                <a:latin typeface="Adobe Clean" pitchFamily="34" charset="0"/>
+                <a:ea typeface="Adobe Clean" pitchFamily="34" charset="-122"/>
+                <a:cs typeface="Adobe Clean" pitchFamily="34" charset="-120"/>
+              </a:rPr>
+              <a:t>2</a:t>
+            </a:r>
+            <a:endParaRPr lang="en-US" sz="900" dirty="0"/>
           </a:p>
         </p:txBody>
       </p:sp>
@@ -13436,6 +14583,84 @@
           </a:p>
         </p:txBody>
       </p:sp>
+      <p:sp>
+        <p:nvSpPr>
+          <p:cNvPr id="24" name="Text 21"/>
+          <p:cNvSpPr txBox="1"/>
+          <p:nvPr/>
+        </p:nvSpPr>
+        <p:spPr>
+          <a:xfrm>
+            <a:off x="457200" y="6473952"/>
+            <a:ext cx="8686800" cy="274320"/>
+          </a:xfrm>
+          <a:prstGeom prst="rect">
+            <a:avLst/>
+          </a:prstGeom>
+          <a:noFill/>
+          <a:ln/>
+        </p:spPr>
+        <p:txBody>
+          <a:bodyPr wrap="square" lIns="0" tIns="0" rIns="0" bIns="0" rtlCol="0" anchor="ctr"/>
+          <a:lstStyle/>
+          <a:p>
+            <a:pPr indent="0" marL="0">
+              <a:buNone/>
+            </a:pPr>
+            <a:r>
+              <a:rPr lang="en-US" sz="900" dirty="0">
+                <a:solidFill>
+                  <a:srgbClr val="A3A3A3"/>
+                </a:solidFill>
+                <a:latin typeface="Adobe Clean" pitchFamily="34" charset="0"/>
+                <a:ea typeface="Adobe Clean" pitchFamily="34" charset="-122"/>
+                <a:cs typeface="Adobe Clean" pitchFamily="34" charset="-120"/>
+              </a:rPr>
+              <a:t>© 2026 Adobe. All Rights Reserved. Adobe Confidential.</a:t>
+            </a:r>
+            <a:endParaRPr lang="en-US" sz="900" dirty="0"/>
+          </a:p>
+        </p:txBody>
+      </p:sp>
+      <p:sp>
+        <p:nvSpPr>
+          <p:cNvPr id="25" name="Text 22"/>
+          <p:cNvSpPr txBox="1"/>
+          <p:nvPr/>
+        </p:nvSpPr>
+        <p:spPr>
+          <a:xfrm>
+            <a:off x="11155680" y="6473952"/>
+            <a:ext cx="640080" cy="274320"/>
+          </a:xfrm>
+          <a:prstGeom prst="rect">
+            <a:avLst/>
+          </a:prstGeom>
+          <a:noFill/>
+          <a:ln/>
+        </p:spPr>
+        <p:txBody>
+          <a:bodyPr wrap="square" lIns="0" tIns="0" rIns="0" bIns="0" rtlCol="0" anchor="ctr"/>
+          <a:lstStyle/>
+          <a:p>
+            <a:pPr algn="r" indent="0" marL="0">
+              <a:buNone/>
+            </a:pPr>
+            <a:r>
+              <a:rPr lang="en-US" sz="900" dirty="0">
+                <a:solidFill>
+                  <a:srgbClr val="A3A3A3"/>
+                </a:solidFill>
+                <a:latin typeface="Adobe Clean" pitchFamily="34" charset="0"/>
+                <a:ea typeface="Adobe Clean" pitchFamily="34" charset="-122"/>
+                <a:cs typeface="Adobe Clean" pitchFamily="34" charset="-120"/>
+              </a:rPr>
+              <a:t>20</a:t>
+            </a:r>
+            <a:endParaRPr lang="en-US" sz="900" dirty="0"/>
+          </a:p>
+        </p:txBody>
+      </p:sp>
     </p:spTree>
   </p:cSld>
   <p:clrMapOvr>
@@ -14362,6 +15587,84 @@
           </a:p>
         </p:txBody>
       </p:sp>
+      <p:sp>
+        <p:nvSpPr>
+          <p:cNvPr id="29" name="Text 26"/>
+          <p:cNvSpPr txBox="1"/>
+          <p:nvPr/>
+        </p:nvSpPr>
+        <p:spPr>
+          <a:xfrm>
+            <a:off x="457200" y="6473952"/>
+            <a:ext cx="8686800" cy="274320"/>
+          </a:xfrm>
+          <a:prstGeom prst="rect">
+            <a:avLst/>
+          </a:prstGeom>
+          <a:noFill/>
+          <a:ln/>
+        </p:spPr>
+        <p:txBody>
+          <a:bodyPr wrap="square" lIns="0" tIns="0" rIns="0" bIns="0" rtlCol="0" anchor="ctr"/>
+          <a:lstStyle/>
+          <a:p>
+            <a:pPr indent="0" marL="0">
+              <a:buNone/>
+            </a:pPr>
+            <a:r>
+              <a:rPr lang="en-US" sz="900" dirty="0">
+                <a:solidFill>
+                  <a:srgbClr val="A3A3A3"/>
+                </a:solidFill>
+                <a:latin typeface="Adobe Clean" pitchFamily="34" charset="0"/>
+                <a:ea typeface="Adobe Clean" pitchFamily="34" charset="-122"/>
+                <a:cs typeface="Adobe Clean" pitchFamily="34" charset="-120"/>
+              </a:rPr>
+              <a:t>© 2026 Adobe. All Rights Reserved. Adobe Confidential.</a:t>
+            </a:r>
+            <a:endParaRPr lang="en-US" sz="900" dirty="0"/>
+          </a:p>
+        </p:txBody>
+      </p:sp>
+      <p:sp>
+        <p:nvSpPr>
+          <p:cNvPr id="30" name="Text 27"/>
+          <p:cNvSpPr txBox="1"/>
+          <p:nvPr/>
+        </p:nvSpPr>
+        <p:spPr>
+          <a:xfrm>
+            <a:off x="11155680" y="6473952"/>
+            <a:ext cx="640080" cy="274320"/>
+          </a:xfrm>
+          <a:prstGeom prst="rect">
+            <a:avLst/>
+          </a:prstGeom>
+          <a:noFill/>
+          <a:ln/>
+        </p:spPr>
+        <p:txBody>
+          <a:bodyPr wrap="square" lIns="0" tIns="0" rIns="0" bIns="0" rtlCol="0" anchor="ctr"/>
+          <a:lstStyle/>
+          <a:p>
+            <a:pPr algn="r" indent="0" marL="0">
+              <a:buNone/>
+            </a:pPr>
+            <a:r>
+              <a:rPr lang="en-US" sz="900" dirty="0">
+                <a:solidFill>
+                  <a:srgbClr val="A3A3A3"/>
+                </a:solidFill>
+                <a:latin typeface="Adobe Clean" pitchFamily="34" charset="0"/>
+                <a:ea typeface="Adobe Clean" pitchFamily="34" charset="-122"/>
+                <a:cs typeface="Adobe Clean" pitchFamily="34" charset="-120"/>
+              </a:rPr>
+              <a:t>21</a:t>
+            </a:r>
+            <a:endParaRPr lang="en-US" sz="900" dirty="0"/>
+          </a:p>
+        </p:txBody>
+      </p:sp>
     </p:spTree>
   </p:cSld>
   <p:clrMapOvr>
@@ -14775,6 +16078,84 @@
           </a:p>
         </p:txBody>
       </p:sp>
+      <p:sp>
+        <p:nvSpPr>
+          <p:cNvPr id="14" name="Text 11"/>
+          <p:cNvSpPr txBox="1"/>
+          <p:nvPr/>
+        </p:nvSpPr>
+        <p:spPr>
+          <a:xfrm>
+            <a:off x="457200" y="6473952"/>
+            <a:ext cx="8686800" cy="274320"/>
+          </a:xfrm>
+          <a:prstGeom prst="rect">
+            <a:avLst/>
+          </a:prstGeom>
+          <a:noFill/>
+          <a:ln/>
+        </p:spPr>
+        <p:txBody>
+          <a:bodyPr wrap="square" lIns="0" tIns="0" rIns="0" bIns="0" rtlCol="0" anchor="ctr"/>
+          <a:lstStyle/>
+          <a:p>
+            <a:pPr indent="0" marL="0">
+              <a:buNone/>
+            </a:pPr>
+            <a:r>
+              <a:rPr lang="en-US" sz="900" dirty="0">
+                <a:solidFill>
+                  <a:srgbClr val="8A8A8A"/>
+                </a:solidFill>
+                <a:latin typeface="Adobe Clean" pitchFamily="34" charset="0"/>
+                <a:ea typeface="Adobe Clean" pitchFamily="34" charset="-122"/>
+                <a:cs typeface="Adobe Clean" pitchFamily="34" charset="-120"/>
+              </a:rPr>
+              <a:t>© 2026 Adobe. All Rights Reserved. Adobe Confidential.</a:t>
+            </a:r>
+            <a:endParaRPr lang="en-US" sz="900" dirty="0"/>
+          </a:p>
+        </p:txBody>
+      </p:sp>
+      <p:sp>
+        <p:nvSpPr>
+          <p:cNvPr id="15" name="Text 12"/>
+          <p:cNvSpPr txBox="1"/>
+          <p:nvPr/>
+        </p:nvSpPr>
+        <p:spPr>
+          <a:xfrm>
+            <a:off x="11155680" y="6473952"/>
+            <a:ext cx="640080" cy="274320"/>
+          </a:xfrm>
+          <a:prstGeom prst="rect">
+            <a:avLst/>
+          </a:prstGeom>
+          <a:noFill/>
+          <a:ln/>
+        </p:spPr>
+        <p:txBody>
+          <a:bodyPr wrap="square" lIns="0" tIns="0" rIns="0" bIns="0" rtlCol="0" anchor="ctr"/>
+          <a:lstStyle/>
+          <a:p>
+            <a:pPr algn="r" indent="0" marL="0">
+              <a:buNone/>
+            </a:pPr>
+            <a:r>
+              <a:rPr lang="en-US" sz="900" dirty="0">
+                <a:solidFill>
+                  <a:srgbClr val="8A8A8A"/>
+                </a:solidFill>
+                <a:latin typeface="Adobe Clean" pitchFamily="34" charset="0"/>
+                <a:ea typeface="Adobe Clean" pitchFamily="34" charset="-122"/>
+                <a:cs typeface="Adobe Clean" pitchFamily="34" charset="-120"/>
+              </a:rPr>
+              <a:t>22</a:t>
+            </a:r>
+            <a:endParaRPr lang="en-US" sz="900" dirty="0"/>
+          </a:p>
+        </p:txBody>
+      </p:sp>
     </p:spTree>
   </p:cSld>
   <p:clrMapOvr>
@@ -15080,6 +16461,84 @@
           </a:p>
         </p:txBody>
       </p:sp>
+      <p:sp>
+        <p:nvSpPr>
+          <p:cNvPr id="11" name="Text 8"/>
+          <p:cNvSpPr txBox="1"/>
+          <p:nvPr/>
+        </p:nvSpPr>
+        <p:spPr>
+          <a:xfrm>
+            <a:off x="457200" y="6473952"/>
+            <a:ext cx="8686800" cy="274320"/>
+          </a:xfrm>
+          <a:prstGeom prst="rect">
+            <a:avLst/>
+          </a:prstGeom>
+          <a:noFill/>
+          <a:ln/>
+        </p:spPr>
+        <p:txBody>
+          <a:bodyPr wrap="square" lIns="0" tIns="0" rIns="0" bIns="0" rtlCol="0" anchor="ctr"/>
+          <a:lstStyle/>
+          <a:p>
+            <a:pPr indent="0" marL="0">
+              <a:buNone/>
+            </a:pPr>
+            <a:r>
+              <a:rPr lang="en-US" sz="900" dirty="0">
+                <a:solidFill>
+                  <a:srgbClr val="A3A3A3"/>
+                </a:solidFill>
+                <a:latin typeface="Adobe Clean" pitchFamily="34" charset="0"/>
+                <a:ea typeface="Adobe Clean" pitchFamily="34" charset="-122"/>
+                <a:cs typeface="Adobe Clean" pitchFamily="34" charset="-120"/>
+              </a:rPr>
+              <a:t>© 2026 Adobe. All Rights Reserved. Adobe Confidential.</a:t>
+            </a:r>
+            <a:endParaRPr lang="en-US" sz="900" dirty="0"/>
+          </a:p>
+        </p:txBody>
+      </p:sp>
+      <p:sp>
+        <p:nvSpPr>
+          <p:cNvPr id="12" name="Text 9"/>
+          <p:cNvSpPr txBox="1"/>
+          <p:nvPr/>
+        </p:nvSpPr>
+        <p:spPr>
+          <a:xfrm>
+            <a:off x="11155680" y="6473952"/>
+            <a:ext cx="640080" cy="274320"/>
+          </a:xfrm>
+          <a:prstGeom prst="rect">
+            <a:avLst/>
+          </a:prstGeom>
+          <a:noFill/>
+          <a:ln/>
+        </p:spPr>
+        <p:txBody>
+          <a:bodyPr wrap="square" lIns="0" tIns="0" rIns="0" bIns="0" rtlCol="0" anchor="ctr"/>
+          <a:lstStyle/>
+          <a:p>
+            <a:pPr algn="r" indent="0" marL="0">
+              <a:buNone/>
+            </a:pPr>
+            <a:r>
+              <a:rPr lang="en-US" sz="900" dirty="0">
+                <a:solidFill>
+                  <a:srgbClr val="A3A3A3"/>
+                </a:solidFill>
+                <a:latin typeface="Adobe Clean" pitchFamily="34" charset="0"/>
+                <a:ea typeface="Adobe Clean" pitchFamily="34" charset="-122"/>
+                <a:cs typeface="Adobe Clean" pitchFamily="34" charset="-120"/>
+              </a:rPr>
+              <a:t>23</a:t>
+            </a:r>
+            <a:endParaRPr lang="en-US" sz="900" dirty="0"/>
+          </a:p>
+        </p:txBody>
+      </p:sp>
     </p:spTree>
   </p:cSld>
   <p:clrMapOvr>
@@ -16264,6 +17723,84 @@
           </a:p>
         </p:txBody>
       </p:sp>
+      <p:sp>
+        <p:nvSpPr>
+          <p:cNvPr id="36" name="Text 33"/>
+          <p:cNvSpPr txBox="1"/>
+          <p:nvPr/>
+        </p:nvSpPr>
+        <p:spPr>
+          <a:xfrm>
+            <a:off x="457200" y="6473952"/>
+            <a:ext cx="8686800" cy="274320"/>
+          </a:xfrm>
+          <a:prstGeom prst="rect">
+            <a:avLst/>
+          </a:prstGeom>
+          <a:noFill/>
+          <a:ln/>
+        </p:spPr>
+        <p:txBody>
+          <a:bodyPr wrap="square" lIns="0" tIns="0" rIns="0" bIns="0" rtlCol="0" anchor="ctr"/>
+          <a:lstStyle/>
+          <a:p>
+            <a:pPr indent="0" marL="0">
+              <a:buNone/>
+            </a:pPr>
+            <a:r>
+              <a:rPr lang="en-US" sz="900" dirty="0">
+                <a:solidFill>
+                  <a:srgbClr val="A3A3A3"/>
+                </a:solidFill>
+                <a:latin typeface="Adobe Clean" pitchFamily="34" charset="0"/>
+                <a:ea typeface="Adobe Clean" pitchFamily="34" charset="-122"/>
+                <a:cs typeface="Adobe Clean" pitchFamily="34" charset="-120"/>
+              </a:rPr>
+              <a:t>© 2026 Adobe. All Rights Reserved. Adobe Confidential.</a:t>
+            </a:r>
+            <a:endParaRPr lang="en-US" sz="900" dirty="0"/>
+          </a:p>
+        </p:txBody>
+      </p:sp>
+      <p:sp>
+        <p:nvSpPr>
+          <p:cNvPr id="37" name="Text 34"/>
+          <p:cNvSpPr txBox="1"/>
+          <p:nvPr/>
+        </p:nvSpPr>
+        <p:spPr>
+          <a:xfrm>
+            <a:off x="11155680" y="6473952"/>
+            <a:ext cx="640080" cy="274320"/>
+          </a:xfrm>
+          <a:prstGeom prst="rect">
+            <a:avLst/>
+          </a:prstGeom>
+          <a:noFill/>
+          <a:ln/>
+        </p:spPr>
+        <p:txBody>
+          <a:bodyPr wrap="square" lIns="0" tIns="0" rIns="0" bIns="0" rtlCol="0" anchor="ctr"/>
+          <a:lstStyle/>
+          <a:p>
+            <a:pPr algn="r" indent="0" marL="0">
+              <a:buNone/>
+            </a:pPr>
+            <a:r>
+              <a:rPr lang="en-US" sz="900" dirty="0">
+                <a:solidFill>
+                  <a:srgbClr val="A3A3A3"/>
+                </a:solidFill>
+                <a:latin typeface="Adobe Clean" pitchFamily="34" charset="0"/>
+                <a:ea typeface="Adobe Clean" pitchFamily="34" charset="-122"/>
+                <a:cs typeface="Adobe Clean" pitchFamily="34" charset="-120"/>
+              </a:rPr>
+              <a:t>3</a:t>
+            </a:r>
+            <a:endParaRPr lang="en-US" sz="900" dirty="0"/>
+          </a:p>
+        </p:txBody>
+      </p:sp>
     </p:spTree>
   </p:cSld>
   <p:clrMapOvr>
@@ -17374,6 +18911,84 @@
           </a:p>
         </p:txBody>
       </p:sp>
+      <p:sp>
+        <p:nvSpPr>
+          <p:cNvPr id="37" name="Text 34"/>
+          <p:cNvSpPr txBox="1"/>
+          <p:nvPr/>
+        </p:nvSpPr>
+        <p:spPr>
+          <a:xfrm>
+            <a:off x="457200" y="6473952"/>
+            <a:ext cx="8686800" cy="274320"/>
+          </a:xfrm>
+          <a:prstGeom prst="rect">
+            <a:avLst/>
+          </a:prstGeom>
+          <a:noFill/>
+          <a:ln/>
+        </p:spPr>
+        <p:txBody>
+          <a:bodyPr wrap="square" lIns="0" tIns="0" rIns="0" bIns="0" rtlCol="0" anchor="ctr"/>
+          <a:lstStyle/>
+          <a:p>
+            <a:pPr indent="0" marL="0">
+              <a:buNone/>
+            </a:pPr>
+            <a:r>
+              <a:rPr lang="en-US" sz="900" dirty="0">
+                <a:solidFill>
+                  <a:srgbClr val="A3A3A3"/>
+                </a:solidFill>
+                <a:latin typeface="Adobe Clean" pitchFamily="34" charset="0"/>
+                <a:ea typeface="Adobe Clean" pitchFamily="34" charset="-122"/>
+                <a:cs typeface="Adobe Clean" pitchFamily="34" charset="-120"/>
+              </a:rPr>
+              <a:t>© 2026 Adobe. All Rights Reserved. Adobe Confidential.</a:t>
+            </a:r>
+            <a:endParaRPr lang="en-US" sz="900" dirty="0"/>
+          </a:p>
+        </p:txBody>
+      </p:sp>
+      <p:sp>
+        <p:nvSpPr>
+          <p:cNvPr id="38" name="Text 35"/>
+          <p:cNvSpPr txBox="1"/>
+          <p:nvPr/>
+        </p:nvSpPr>
+        <p:spPr>
+          <a:xfrm>
+            <a:off x="11155680" y="6473952"/>
+            <a:ext cx="640080" cy="274320"/>
+          </a:xfrm>
+          <a:prstGeom prst="rect">
+            <a:avLst/>
+          </a:prstGeom>
+          <a:noFill/>
+          <a:ln/>
+        </p:spPr>
+        <p:txBody>
+          <a:bodyPr wrap="square" lIns="0" tIns="0" rIns="0" bIns="0" rtlCol="0" anchor="ctr"/>
+          <a:lstStyle/>
+          <a:p>
+            <a:pPr algn="r" indent="0" marL="0">
+              <a:buNone/>
+            </a:pPr>
+            <a:r>
+              <a:rPr lang="en-US" sz="900" dirty="0">
+                <a:solidFill>
+                  <a:srgbClr val="A3A3A3"/>
+                </a:solidFill>
+                <a:latin typeface="Adobe Clean" pitchFamily="34" charset="0"/>
+                <a:ea typeface="Adobe Clean" pitchFamily="34" charset="-122"/>
+                <a:cs typeface="Adobe Clean" pitchFamily="34" charset="-120"/>
+              </a:rPr>
+              <a:t>4</a:t>
+            </a:r>
+            <a:endParaRPr lang="en-US" sz="900" dirty="0"/>
+          </a:p>
+        </p:txBody>
+      </p:sp>
     </p:spTree>
   </p:cSld>
   <p:clrMapOvr>
@@ -17563,6 +19178,84 @@
           </a:p>
         </p:txBody>
       </p:sp>
+      <p:sp>
+        <p:nvSpPr>
+          <p:cNvPr id="8" name="Text 5"/>
+          <p:cNvSpPr txBox="1"/>
+          <p:nvPr/>
+        </p:nvSpPr>
+        <p:spPr>
+          <a:xfrm>
+            <a:off x="457200" y="6473952"/>
+            <a:ext cx="8686800" cy="274320"/>
+          </a:xfrm>
+          <a:prstGeom prst="rect">
+            <a:avLst/>
+          </a:prstGeom>
+          <a:noFill/>
+          <a:ln/>
+        </p:spPr>
+        <p:txBody>
+          <a:bodyPr wrap="square" lIns="0" tIns="0" rIns="0" bIns="0" rtlCol="0" anchor="ctr"/>
+          <a:lstStyle/>
+          <a:p>
+            <a:pPr indent="0" marL="0">
+              <a:buNone/>
+            </a:pPr>
+            <a:r>
+              <a:rPr lang="en-US" sz="900" dirty="0">
+                <a:solidFill>
+                  <a:srgbClr val="8A8A8A"/>
+                </a:solidFill>
+                <a:latin typeface="Adobe Clean" pitchFamily="34" charset="0"/>
+                <a:ea typeface="Adobe Clean" pitchFamily="34" charset="-122"/>
+                <a:cs typeface="Adobe Clean" pitchFamily="34" charset="-120"/>
+              </a:rPr>
+              <a:t>© 2026 Adobe. All Rights Reserved. Adobe Confidential.</a:t>
+            </a:r>
+            <a:endParaRPr lang="en-US" sz="900" dirty="0"/>
+          </a:p>
+        </p:txBody>
+      </p:sp>
+      <p:sp>
+        <p:nvSpPr>
+          <p:cNvPr id="9" name="Text 6"/>
+          <p:cNvSpPr txBox="1"/>
+          <p:nvPr/>
+        </p:nvSpPr>
+        <p:spPr>
+          <a:xfrm>
+            <a:off x="11155680" y="6473952"/>
+            <a:ext cx="640080" cy="274320"/>
+          </a:xfrm>
+          <a:prstGeom prst="rect">
+            <a:avLst/>
+          </a:prstGeom>
+          <a:noFill/>
+          <a:ln/>
+        </p:spPr>
+        <p:txBody>
+          <a:bodyPr wrap="square" lIns="0" tIns="0" rIns="0" bIns="0" rtlCol="0" anchor="ctr"/>
+          <a:lstStyle/>
+          <a:p>
+            <a:pPr algn="r" indent="0" marL="0">
+              <a:buNone/>
+            </a:pPr>
+            <a:r>
+              <a:rPr lang="en-US" sz="900" dirty="0">
+                <a:solidFill>
+                  <a:srgbClr val="8A8A8A"/>
+                </a:solidFill>
+                <a:latin typeface="Adobe Clean" pitchFamily="34" charset="0"/>
+                <a:ea typeface="Adobe Clean" pitchFamily="34" charset="-122"/>
+                <a:cs typeface="Adobe Clean" pitchFamily="34" charset="-120"/>
+              </a:rPr>
+              <a:t>5</a:t>
+            </a:r>
+            <a:endParaRPr lang="en-US" sz="900" dirty="0"/>
+          </a:p>
+        </p:txBody>
+      </p:sp>
     </p:spTree>
   </p:cSld>
   <p:clrMapOvr>
@@ -18322,6 +20015,84 @@
           </a:p>
         </p:txBody>
       </p:sp>
+      <p:sp>
+        <p:nvSpPr>
+          <p:cNvPr id="24" name="Text 21"/>
+          <p:cNvSpPr txBox="1"/>
+          <p:nvPr/>
+        </p:nvSpPr>
+        <p:spPr>
+          <a:xfrm>
+            <a:off x="457200" y="6473952"/>
+            <a:ext cx="8686800" cy="274320"/>
+          </a:xfrm>
+          <a:prstGeom prst="rect">
+            <a:avLst/>
+          </a:prstGeom>
+          <a:noFill/>
+          <a:ln/>
+        </p:spPr>
+        <p:txBody>
+          <a:bodyPr wrap="square" lIns="0" tIns="0" rIns="0" bIns="0" rtlCol="0" anchor="ctr"/>
+          <a:lstStyle/>
+          <a:p>
+            <a:pPr indent="0" marL="0">
+              <a:buNone/>
+            </a:pPr>
+            <a:r>
+              <a:rPr lang="en-US" sz="900" dirty="0">
+                <a:solidFill>
+                  <a:srgbClr val="A3A3A3"/>
+                </a:solidFill>
+                <a:latin typeface="Adobe Clean" pitchFamily="34" charset="0"/>
+                <a:ea typeface="Adobe Clean" pitchFamily="34" charset="-122"/>
+                <a:cs typeface="Adobe Clean" pitchFamily="34" charset="-120"/>
+              </a:rPr>
+              <a:t>© 2026 Adobe. All Rights Reserved. Adobe Confidential.</a:t>
+            </a:r>
+            <a:endParaRPr lang="en-US" sz="900" dirty="0"/>
+          </a:p>
+        </p:txBody>
+      </p:sp>
+      <p:sp>
+        <p:nvSpPr>
+          <p:cNvPr id="25" name="Text 22"/>
+          <p:cNvSpPr txBox="1"/>
+          <p:nvPr/>
+        </p:nvSpPr>
+        <p:spPr>
+          <a:xfrm>
+            <a:off x="11155680" y="6473952"/>
+            <a:ext cx="640080" cy="274320"/>
+          </a:xfrm>
+          <a:prstGeom prst="rect">
+            <a:avLst/>
+          </a:prstGeom>
+          <a:noFill/>
+          <a:ln/>
+        </p:spPr>
+        <p:txBody>
+          <a:bodyPr wrap="square" lIns="0" tIns="0" rIns="0" bIns="0" rtlCol="0" anchor="ctr"/>
+          <a:lstStyle/>
+          <a:p>
+            <a:pPr algn="r" indent="0" marL="0">
+              <a:buNone/>
+            </a:pPr>
+            <a:r>
+              <a:rPr lang="en-US" sz="900" dirty="0">
+                <a:solidFill>
+                  <a:srgbClr val="A3A3A3"/>
+                </a:solidFill>
+                <a:latin typeface="Adobe Clean" pitchFamily="34" charset="0"/>
+                <a:ea typeface="Adobe Clean" pitchFamily="34" charset="-122"/>
+                <a:cs typeface="Adobe Clean" pitchFamily="34" charset="-120"/>
+              </a:rPr>
+              <a:t>6</a:t>
+            </a:r>
+            <a:endParaRPr lang="en-US" sz="900" dirty="0"/>
+          </a:p>
+        </p:txBody>
+      </p:sp>
     </p:spTree>
   </p:cSld>
   <p:clrMapOvr>
@@ -18918,6 +20689,84 @@
           </a:p>
         </p:txBody>
       </p:sp>
+      <p:sp>
+        <p:nvSpPr>
+          <p:cNvPr id="19" name="Text 16"/>
+          <p:cNvSpPr txBox="1"/>
+          <p:nvPr/>
+        </p:nvSpPr>
+        <p:spPr>
+          <a:xfrm>
+            <a:off x="457200" y="6473952"/>
+            <a:ext cx="8686800" cy="274320"/>
+          </a:xfrm>
+          <a:prstGeom prst="rect">
+            <a:avLst/>
+          </a:prstGeom>
+          <a:noFill/>
+          <a:ln/>
+        </p:spPr>
+        <p:txBody>
+          <a:bodyPr wrap="square" lIns="0" tIns="0" rIns="0" bIns="0" rtlCol="0" anchor="ctr"/>
+          <a:lstStyle/>
+          <a:p>
+            <a:pPr indent="0" marL="0">
+              <a:buNone/>
+            </a:pPr>
+            <a:r>
+              <a:rPr lang="en-US" sz="900" dirty="0">
+                <a:solidFill>
+                  <a:srgbClr val="A3A3A3"/>
+                </a:solidFill>
+                <a:latin typeface="Adobe Clean" pitchFamily="34" charset="0"/>
+                <a:ea typeface="Adobe Clean" pitchFamily="34" charset="-122"/>
+                <a:cs typeface="Adobe Clean" pitchFamily="34" charset="-120"/>
+              </a:rPr>
+              <a:t>© 2026 Adobe. All Rights Reserved. Adobe Confidential.</a:t>
+            </a:r>
+            <a:endParaRPr lang="en-US" sz="900" dirty="0"/>
+          </a:p>
+        </p:txBody>
+      </p:sp>
+      <p:sp>
+        <p:nvSpPr>
+          <p:cNvPr id="20" name="Text 17"/>
+          <p:cNvSpPr txBox="1"/>
+          <p:nvPr/>
+        </p:nvSpPr>
+        <p:spPr>
+          <a:xfrm>
+            <a:off x="11155680" y="6473952"/>
+            <a:ext cx="640080" cy="274320"/>
+          </a:xfrm>
+          <a:prstGeom prst="rect">
+            <a:avLst/>
+          </a:prstGeom>
+          <a:noFill/>
+          <a:ln/>
+        </p:spPr>
+        <p:txBody>
+          <a:bodyPr wrap="square" lIns="0" tIns="0" rIns="0" bIns="0" rtlCol="0" anchor="ctr"/>
+          <a:lstStyle/>
+          <a:p>
+            <a:pPr algn="r" indent="0" marL="0">
+              <a:buNone/>
+            </a:pPr>
+            <a:r>
+              <a:rPr lang="en-US" sz="900" dirty="0">
+                <a:solidFill>
+                  <a:srgbClr val="A3A3A3"/>
+                </a:solidFill>
+                <a:latin typeface="Adobe Clean" pitchFamily="34" charset="0"/>
+                <a:ea typeface="Adobe Clean" pitchFamily="34" charset="-122"/>
+                <a:cs typeface="Adobe Clean" pitchFamily="34" charset="-120"/>
+              </a:rPr>
+              <a:t>7</a:t>
+            </a:r>
+            <a:endParaRPr lang="en-US" sz="900" dirty="0"/>
+          </a:p>
+        </p:txBody>
+      </p:sp>
     </p:spTree>
   </p:cSld>
   <p:clrMapOvr>
@@ -19625,6 +21474,84 @@
           </a:p>
         </p:txBody>
       </p:sp>
+      <p:sp>
+        <p:nvSpPr>
+          <p:cNvPr id="21" name="Text 18"/>
+          <p:cNvSpPr txBox="1"/>
+          <p:nvPr/>
+        </p:nvSpPr>
+        <p:spPr>
+          <a:xfrm>
+            <a:off x="457200" y="6473952"/>
+            <a:ext cx="8686800" cy="274320"/>
+          </a:xfrm>
+          <a:prstGeom prst="rect">
+            <a:avLst/>
+          </a:prstGeom>
+          <a:noFill/>
+          <a:ln/>
+        </p:spPr>
+        <p:txBody>
+          <a:bodyPr wrap="square" lIns="0" tIns="0" rIns="0" bIns="0" rtlCol="0" anchor="ctr"/>
+          <a:lstStyle/>
+          <a:p>
+            <a:pPr indent="0" marL="0">
+              <a:buNone/>
+            </a:pPr>
+            <a:r>
+              <a:rPr lang="en-US" sz="900" dirty="0">
+                <a:solidFill>
+                  <a:srgbClr val="A3A3A3"/>
+                </a:solidFill>
+                <a:latin typeface="Adobe Clean" pitchFamily="34" charset="0"/>
+                <a:ea typeface="Adobe Clean" pitchFamily="34" charset="-122"/>
+                <a:cs typeface="Adobe Clean" pitchFamily="34" charset="-120"/>
+              </a:rPr>
+              <a:t>© 2026 Adobe. All Rights Reserved. Adobe Confidential.</a:t>
+            </a:r>
+            <a:endParaRPr lang="en-US" sz="900" dirty="0"/>
+          </a:p>
+        </p:txBody>
+      </p:sp>
+      <p:sp>
+        <p:nvSpPr>
+          <p:cNvPr id="22" name="Text 19"/>
+          <p:cNvSpPr txBox="1"/>
+          <p:nvPr/>
+        </p:nvSpPr>
+        <p:spPr>
+          <a:xfrm>
+            <a:off x="11155680" y="6473952"/>
+            <a:ext cx="640080" cy="274320"/>
+          </a:xfrm>
+          <a:prstGeom prst="rect">
+            <a:avLst/>
+          </a:prstGeom>
+          <a:noFill/>
+          <a:ln/>
+        </p:spPr>
+        <p:txBody>
+          <a:bodyPr wrap="square" lIns="0" tIns="0" rIns="0" bIns="0" rtlCol="0" anchor="ctr"/>
+          <a:lstStyle/>
+          <a:p>
+            <a:pPr algn="r" indent="0" marL="0">
+              <a:buNone/>
+            </a:pPr>
+            <a:r>
+              <a:rPr lang="en-US" sz="900" dirty="0">
+                <a:solidFill>
+                  <a:srgbClr val="A3A3A3"/>
+                </a:solidFill>
+                <a:latin typeface="Adobe Clean" pitchFamily="34" charset="0"/>
+                <a:ea typeface="Adobe Clean" pitchFamily="34" charset="-122"/>
+                <a:cs typeface="Adobe Clean" pitchFamily="34" charset="-120"/>
+              </a:rPr>
+              <a:t>8</a:t>
+            </a:r>
+            <a:endParaRPr lang="en-US" sz="900" dirty="0"/>
+          </a:p>
+        </p:txBody>
+      </p:sp>
     </p:spTree>
   </p:cSld>
   <p:clrMapOvr>
@@ -20299,6 +22226,84 @@
               <a:t>⚠️  Event listens for the data-layer name (purchase). Action Type = the XDM eventType (commerce.purchases). Don't mix them up!</a:t>
             </a:r>
             <a:endParaRPr lang="en-US" sz="1350" dirty="0"/>
+          </a:p>
+        </p:txBody>
+      </p:sp>
+      <p:sp>
+        <p:nvSpPr>
+          <p:cNvPr id="21" name="Text 18"/>
+          <p:cNvSpPr txBox="1"/>
+          <p:nvPr/>
+        </p:nvSpPr>
+        <p:spPr>
+          <a:xfrm>
+            <a:off x="457200" y="6473952"/>
+            <a:ext cx="8686800" cy="274320"/>
+          </a:xfrm>
+          <a:prstGeom prst="rect">
+            <a:avLst/>
+          </a:prstGeom>
+          <a:noFill/>
+          <a:ln/>
+        </p:spPr>
+        <p:txBody>
+          <a:bodyPr wrap="square" lIns="0" tIns="0" rIns="0" bIns="0" rtlCol="0" anchor="ctr"/>
+          <a:lstStyle/>
+          <a:p>
+            <a:pPr indent="0" marL="0">
+              <a:buNone/>
+            </a:pPr>
+            <a:r>
+              <a:rPr lang="en-US" sz="900" dirty="0">
+                <a:solidFill>
+                  <a:srgbClr val="A3A3A3"/>
+                </a:solidFill>
+                <a:latin typeface="Adobe Clean" pitchFamily="34" charset="0"/>
+                <a:ea typeface="Adobe Clean" pitchFamily="34" charset="-122"/>
+                <a:cs typeface="Adobe Clean" pitchFamily="34" charset="-120"/>
+              </a:rPr>
+              <a:t>© 2026 Adobe. All Rights Reserved. Adobe Confidential.</a:t>
+            </a:r>
+            <a:endParaRPr lang="en-US" sz="900" dirty="0"/>
+          </a:p>
+        </p:txBody>
+      </p:sp>
+      <p:sp>
+        <p:nvSpPr>
+          <p:cNvPr id="22" name="Text 19"/>
+          <p:cNvSpPr txBox="1"/>
+          <p:nvPr/>
+        </p:nvSpPr>
+        <p:spPr>
+          <a:xfrm>
+            <a:off x="11155680" y="6473952"/>
+            <a:ext cx="640080" cy="274320"/>
+          </a:xfrm>
+          <a:prstGeom prst="rect">
+            <a:avLst/>
+          </a:prstGeom>
+          <a:noFill/>
+          <a:ln/>
+        </p:spPr>
+        <p:txBody>
+          <a:bodyPr wrap="square" lIns="0" tIns="0" rIns="0" bIns="0" rtlCol="0" anchor="ctr"/>
+          <a:lstStyle/>
+          <a:p>
+            <a:pPr algn="r" indent="0" marL="0">
+              <a:buNone/>
+            </a:pPr>
+            <a:r>
+              <a:rPr lang="en-US" sz="900" dirty="0">
+                <a:solidFill>
+                  <a:srgbClr val="A3A3A3"/>
+                </a:solidFill>
+                <a:latin typeface="Adobe Clean" pitchFamily="34" charset="0"/>
+                <a:ea typeface="Adobe Clean" pitchFamily="34" charset="-122"/>
+                <a:cs typeface="Adobe Clean" pitchFamily="34" charset="-120"/>
+              </a:rPr>
+              <a:t>9</a:t>
+            </a:r>
+            <a:endParaRPr lang="en-US" sz="900" dirty="0"/>
           </a:p>
         </p:txBody>
       </p:sp>

</xml_diff>